<commit_message>
Update project files and models
</commit_message>
<xml_diff>
--- a/PC_Performance_Predictor_ML_Review.pptx
+++ b/PC_Performance_Predictor_ML_Review.pptx
@@ -5,7 +5,7 @@
     <p:sldMasterId id="2147483648" r:id="rId1"/>
   </p:sldMasterIdLst>
   <p:notesMasterIdLst>
-    <p:notesMasterId r:id="rId27"/>
+    <p:notesMasterId r:id="rId28"/>
   </p:notesMasterIdLst>
   <p:sldIdLst>
     <p:sldId id="256" r:id="rId2"/>
@@ -33,6 +33,7 @@
     <p:sldId id="278" r:id="rId24"/>
     <p:sldId id="279" r:id="rId25"/>
     <p:sldId id="280" r:id="rId26"/>
+    <p:sldId id="281" r:id="rId27"/>
   </p:sldIdLst>
   <p:sldSz cx="12192000" cy="6858000"/>
   <p:notesSz cx="6858000" cy="12192000"/>
@@ -131,19 +132,19 @@
   <p:extLst>
     <p:ext uri="{521415D9-36F7-43E2-AB2F-B90AF26B5E84}">
       <p14:sectionLst xmlns:p14="http://schemas.microsoft.com/office/powerpoint/2010/main">
-        <p14:section name="Introduction" id="{A11B0B6F-E3E0-CC76-5660-02CFACB92FD9}">
+        <p14:section name="Introduction" id="{26BAAE11-44A2-BBC2-370B-4C2AD4852016}">
           <p14:sldIdLst>
             <p14:sldId id="256"/>
           </p14:sldIdLst>
         </p14:section>
-        <p14:section name="Problem &amp; Approach" id="{E15B6F74-EE83-1BBB-3DF2-4923CB09174E}">
+        <p14:section name="Problem &amp; Approach" id="{C2337C31-D78F-BE20-B52C-F80D42637596}">
           <p14:sldIdLst>
             <p14:sldId id="257"/>
             <p14:sldId id="258"/>
             <p14:sldId id="259"/>
           </p14:sldIdLst>
         </p14:section>
-        <p14:section name="Data &amp; Preprocessing" id="{EC2171A9-DC63-FEA3-58AF-F4E909AE541A}">
+        <p14:section name="Data &amp; Preprocessing" id="{053D0E70-CF82-3E9C-104A-28EAD05D672D}">
           <p14:sldIdLst>
             <p14:sldId id="260"/>
             <p14:sldId id="261"/>
@@ -152,20 +153,20 @@
             <p14:sldId id="264"/>
           </p14:sldIdLst>
         </p14:section>
-        <p14:section name="Modelling" id="{F89D0BAF-2272-ACD0-6A0D-177975EDCD92}">
+        <p14:section name="Modelling" id="{7E71879D-5325-C4FA-9091-489B7E2F2E7C}">
           <p14:sldIdLst>
             <p14:sldId id="265"/>
             <p14:sldId id="266"/>
           </p14:sldIdLst>
         </p14:section>
-        <p14:section name="Exploration" id="{42B6F0AB-9111-43E0-F89E-B0A7F00B0CAA}">
+        <p14:section name="Exploration" id="{B521C21B-EBE3-23B8-AF5F-0A20CF2105FD}">
           <p14:sldIdLst>
             <p14:sldId id="267"/>
             <p14:sldId id="268"/>
             <p14:sldId id="269"/>
           </p14:sldIdLst>
         </p14:section>
-        <p14:section name="Training &amp; Results" id="{7206BB5C-0391-235F-F36C-8CC99B20522C}">
+        <p14:section name="Training &amp; Results" id="{0D4F11EB-4A17-408B-D4F7-51FCB65E318B}">
           <p14:sldIdLst>
             <p14:sldId id="270"/>
             <p14:sldId id="271"/>
@@ -176,16 +177,17 @@
             <p14:sldId id="276"/>
           </p14:sldIdLst>
         </p14:section>
-        <p14:section name="Application" id="{1A62302D-3504-E04C-A514-0DEF7EE24032}">
+        <p14:section name="Application" id="{52BBADB3-2995-8EB8-F8E7-28719091EEE7}">
           <p14:sldIdLst>
             <p14:sldId id="277"/>
             <p14:sldId id="278"/>
+            <p14:sldId id="279"/>
           </p14:sldIdLst>
         </p14:section>
-        <p14:section name="Wrap-up" id="{497ADD03-A588-5AA3-8915-709F5A30810B}">
+        <p14:section name="Wrap-up" id="{E58874A8-4868-7422-654A-A51CCB03FF61}">
           <p14:sldIdLst>
-            <p14:sldId id="279"/>
             <p14:sldId id="280"/>
+            <p14:sldId id="281"/>
           </p14:sldIdLst>
         </p14:section>
       </p14:sectionLst>
@@ -195,73 +197,6 @@
     </p:ext>
   </p:extLst>
 </p:presentation>
-</file>
-
-<file path=ppt/changesInfos/changesInfo1.xml><?xml version="1.0" encoding="utf-8"?>
-<pc:chgInfo xmlns:a="http://schemas.openxmlformats.org/drawingml/2006/main" xmlns:r="http://schemas.openxmlformats.org/officeDocument/2006/relationships" xmlns:ac="http://schemas.microsoft.com/office/drawing/2013/main/command" xmlns:pc="http://schemas.microsoft.com/office/powerpoint/2013/main/command">
-  <pc:docChgLst>
-    <pc:chgData name="Pavan Guvvala" userId="200c0c369636e9f2" providerId="LiveId" clId="{3D5FEF91-7A47-4453-8BC9-B7C7015E390B}"/>
-    <pc:docChg chg="undo custSel modSld">
-      <pc:chgData name="Pavan Guvvala" userId="200c0c369636e9f2" providerId="LiveId" clId="{3D5FEF91-7A47-4453-8BC9-B7C7015E390B}" dt="2026-10-10T12:20:37.006" v="7" actId="478"/>
-      <pc:docMkLst>
-        <pc:docMk/>
-      </pc:docMkLst>
-      <pc:sldChg chg="modSp mod">
-        <pc:chgData name="Pavan Guvvala" userId="200c0c369636e9f2" providerId="LiveId" clId="{3D5FEF91-7A47-4453-8BC9-B7C7015E390B}" dt="2026-10-10T12:15:44.231" v="3" actId="14100"/>
-        <pc:sldMkLst>
-          <pc:docMk/>
-          <pc:sldMk cId="0" sldId="257"/>
-        </pc:sldMkLst>
-        <pc:spChg chg="mod">
-          <ac:chgData name="Pavan Guvvala" userId="200c0c369636e9f2" providerId="LiveId" clId="{3D5FEF91-7A47-4453-8BC9-B7C7015E390B}" dt="2026-10-10T12:15:44.231" v="3" actId="14100"/>
-          <ac:spMkLst>
-            <pc:docMk/>
-            <pc:sldMk cId="0" sldId="257"/>
-            <ac:spMk id="4" creationId="{00000000-0000-0000-0000-000000000000}"/>
-          </ac:spMkLst>
-        </pc:spChg>
-      </pc:sldChg>
-      <pc:sldChg chg="modSp mod">
-        <pc:chgData name="Pavan Guvvala" userId="200c0c369636e9f2" providerId="LiveId" clId="{3D5FEF91-7A47-4453-8BC9-B7C7015E390B}" dt="2026-10-10T12:17:26.791" v="5" actId="20577"/>
-        <pc:sldMkLst>
-          <pc:docMk/>
-          <pc:sldMk cId="0" sldId="260"/>
-        </pc:sldMkLst>
-        <pc:spChg chg="mod">
-          <ac:chgData name="Pavan Guvvala" userId="200c0c369636e9f2" providerId="LiveId" clId="{3D5FEF91-7A47-4453-8BC9-B7C7015E390B}" dt="2026-10-10T12:17:26.791" v="5" actId="20577"/>
-          <ac:spMkLst>
-            <pc:docMk/>
-            <pc:sldMk cId="0" sldId="260"/>
-            <ac:spMk id="4" creationId="{00000000-0000-0000-0000-000000000000}"/>
-          </ac:spMkLst>
-        </pc:spChg>
-        <pc:graphicFrameChg chg="modGraphic">
-          <ac:chgData name="Pavan Guvvala" userId="200c0c369636e9f2" providerId="LiveId" clId="{3D5FEF91-7A47-4453-8BC9-B7C7015E390B}" dt="2026-10-10T12:17:18.704" v="4" actId="20577"/>
-          <ac:graphicFrameMkLst>
-            <pc:docMk/>
-            <pc:sldMk cId="0" sldId="260"/>
-            <ac:graphicFrameMk id="6" creationId="{00000000-0000-0000-0000-000000000000}"/>
-          </ac:graphicFrameMkLst>
-        </pc:graphicFrameChg>
-      </pc:sldChg>
-      <pc:sldChg chg="delSp modSp mod">
-        <pc:chgData name="Pavan Guvvala" userId="200c0c369636e9f2" providerId="LiveId" clId="{3D5FEF91-7A47-4453-8BC9-B7C7015E390B}" dt="2026-10-10T12:20:37.006" v="7" actId="478"/>
-        <pc:sldMkLst>
-          <pc:docMk/>
-          <pc:sldMk cId="0" sldId="271"/>
-        </pc:sldMkLst>
-        <pc:spChg chg="del mod">
-          <ac:chgData name="Pavan Guvvala" userId="200c0c369636e9f2" providerId="LiveId" clId="{3D5FEF91-7A47-4453-8BC9-B7C7015E390B}" dt="2026-10-10T12:20:37.006" v="7" actId="478"/>
-          <ac:spMkLst>
-            <pc:docMk/>
-            <pc:sldMk cId="0" sldId="271"/>
-            <ac:spMk id="4" creationId="{00000000-0000-0000-0000-000000000000}"/>
-          </ac:spMkLst>
-        </pc:spChg>
-      </pc:sldChg>
-    </pc:docChg>
-  </pc:docChgLst>
-</pc:chgInfo>
 </file>
 
 <file path=ppt/charts/chart1.xml><?xml version="1.0" encoding="utf-8"?>
@@ -333,7 +268,7 @@
             <c:bubble3D val="0"/>
             <c:extLst>
               <c:ext xmlns:c16="http://schemas.microsoft.com/office/drawing/2014/chart" uri="{C3380CC4-5D6E-409C-BE32-E72D297353CC}">
-                <c16:uniqueId val="{00000001-8DC3-4546-AA73-9F66FD065CE3}"/>
+                <c16:uniqueId val="{00000001-E67B-45F8-97CF-6029235F9891}"/>
               </c:ext>
             </c:extLst>
           </c:dPt>
@@ -343,7 +278,7 @@
             <c:bubble3D val="0"/>
             <c:extLst>
               <c:ext xmlns:c16="http://schemas.microsoft.com/office/drawing/2014/chart" uri="{C3380CC4-5D6E-409C-BE32-E72D297353CC}">
-                <c16:uniqueId val="{00000003-8DC3-4546-AA73-9F66FD065CE3}"/>
+                <c16:uniqueId val="{00000003-E67B-45F8-97CF-6029235F9891}"/>
               </c:ext>
             </c:extLst>
           </c:dPt>
@@ -353,7 +288,7 @@
             <c:bubble3D val="0"/>
             <c:extLst>
               <c:ext xmlns:c16="http://schemas.microsoft.com/office/drawing/2014/chart" uri="{C3380CC4-5D6E-409C-BE32-E72D297353CC}">
-                <c16:uniqueId val="{00000005-8DC3-4546-AA73-9F66FD065CE3}"/>
+                <c16:uniqueId val="{00000005-E67B-45F8-97CF-6029235F9891}"/>
               </c:ext>
             </c:extLst>
           </c:dPt>
@@ -363,7 +298,7 @@
             <c:bubble3D val="0"/>
             <c:extLst>
               <c:ext xmlns:c16="http://schemas.microsoft.com/office/drawing/2014/chart" uri="{C3380CC4-5D6E-409C-BE32-E72D297353CC}">
-                <c16:uniqueId val="{00000007-8DC3-4546-AA73-9F66FD065CE3}"/>
+                <c16:uniqueId val="{00000007-E67B-45F8-97CF-6029235F9891}"/>
               </c:ext>
             </c:extLst>
           </c:dPt>
@@ -373,7 +308,7 @@
             <c:bubble3D val="0"/>
             <c:extLst>
               <c:ext xmlns:c16="http://schemas.microsoft.com/office/drawing/2014/chart" uri="{C3380CC4-5D6E-409C-BE32-E72D297353CC}">
-                <c16:uniqueId val="{00000009-8DC3-4546-AA73-9F66FD065CE3}"/>
+                <c16:uniqueId val="{00000009-E67B-45F8-97CF-6029235F9891}"/>
               </c:ext>
             </c:extLst>
           </c:dPt>
@@ -383,7 +318,7 @@
             <c:bubble3D val="0"/>
             <c:extLst>
               <c:ext xmlns:c16="http://schemas.microsoft.com/office/drawing/2014/chart" uri="{C3380CC4-5D6E-409C-BE32-E72D297353CC}">
-                <c16:uniqueId val="{0000000B-8DC3-4546-AA73-9F66FD065CE3}"/>
+                <c16:uniqueId val="{0000000B-E67B-45F8-97CF-6029235F9891}"/>
               </c:ext>
             </c:extLst>
           </c:dPt>
@@ -399,7 +334,7 @@
             </c:spPr>
             <c:extLst>
               <c:ext xmlns:c16="http://schemas.microsoft.com/office/drawing/2014/chart" uri="{C3380CC4-5D6E-409C-BE32-E72D297353CC}">
-                <c16:uniqueId val="{0000000D-8DC3-4546-AA73-9F66FD065CE3}"/>
+                <c16:uniqueId val="{0000000D-E67B-45F8-97CF-6029235F9891}"/>
               </c:ext>
             </c:extLst>
           </c:dPt>
@@ -415,7 +350,7 @@
             </c:spPr>
             <c:extLst>
               <c:ext xmlns:c16="http://schemas.microsoft.com/office/drawing/2014/chart" uri="{C3380CC4-5D6E-409C-BE32-E72D297353CC}">
-                <c16:uniqueId val="{0000000F-8DC3-4546-AA73-9F66FD065CE3}"/>
+                <c16:uniqueId val="{0000000F-E67B-45F8-97CF-6029235F9891}"/>
               </c:ext>
             </c:extLst>
           </c:dPt>
@@ -523,7 +458,7 @@
           </c:val>
           <c:extLst>
             <c:ext xmlns:c16="http://schemas.microsoft.com/office/drawing/2014/chart" uri="{C3380CC4-5D6E-409C-BE32-E72D297353CC}">
-              <c16:uniqueId val="{00000010-8DC3-4546-AA73-9F66FD065CE3}"/>
+              <c16:uniqueId val="{00000010-E67B-45F8-97CF-6029235F9891}"/>
             </c:ext>
           </c:extLst>
         </c:ser>
@@ -832,7 +767,7 @@
           </c:val>
           <c:extLst>
             <c:ext xmlns:c16="http://schemas.microsoft.com/office/drawing/2014/chart" uri="{C3380CC4-5D6E-409C-BE32-E72D297353CC}">
-              <c16:uniqueId val="{00000000-99E1-4664-9A80-2D6E95B7410F}"/>
+              <c16:uniqueId val="{00000000-AEE5-4909-A338-D0B82B097523}"/>
             </c:ext>
           </c:extLst>
         </c:ser>
@@ -989,7 +924,7 @@
               </a:defRPr>
             </a:pPr>
             <a:r>
-              <a:rPr sz="1400" b="0" i="0" u="none" strike="noStrike">
+              <a:rPr lang="en-US" sz="1400" b="0" i="0" u="none" strike="noStrike">
                 <a:solidFill>
                   <a:srgbClr val="262626"/>
                 </a:solidFill>
@@ -1103,7 +1038,7 @@
           </c:val>
           <c:extLst>
             <c:ext xmlns:c16="http://schemas.microsoft.com/office/drawing/2014/chart" uri="{C3380CC4-5D6E-409C-BE32-E72D297353CC}">
-              <c16:uniqueId val="{00000000-5B74-492D-9643-7748663CCEDA}"/>
+              <c16:uniqueId val="{00000000-6E45-4B07-BA2C-AA36C303994D}"/>
             </c:ext>
           </c:extLst>
         </c:ser>
@@ -1201,7 +1136,7 @@
           </c:val>
           <c:extLst>
             <c:ext xmlns:c16="http://schemas.microsoft.com/office/drawing/2014/chart" uri="{C3380CC4-5D6E-409C-BE32-E72D297353CC}">
-              <c16:uniqueId val="{00000001-5B74-492D-9643-7748663CCEDA}"/>
+              <c16:uniqueId val="{00000001-6E45-4B07-BA2C-AA36C303994D}"/>
             </c:ext>
           </c:extLst>
         </c:ser>
@@ -1378,7 +1313,7 @@
               </a:defRPr>
             </a:pPr>
             <a:r>
-              <a:rPr sz="1400" b="0" i="0" u="none" strike="noStrike">
+              <a:rPr lang="en-US" sz="1400" b="0" i="0" u="none" strike="noStrike">
                 <a:solidFill>
                   <a:srgbClr val="262626"/>
                 </a:solidFill>
@@ -1538,7 +1473,7 @@
           <c:smooth val="0"/>
           <c:extLst>
             <c:ext xmlns:c16="http://schemas.microsoft.com/office/drawing/2014/chart" uri="{C3380CC4-5D6E-409C-BE32-E72D297353CC}">
-              <c16:uniqueId val="{00000000-2E67-49B8-9438-B45DE01DA86B}"/>
+              <c16:uniqueId val="{00000000-0BC1-47C7-A1B0-4B90F182E5DD}"/>
             </c:ext>
           </c:extLst>
         </c:ser>
@@ -1578,7 +1513,7 @@
                   </a:defRPr>
                 </a:pPr>
                 <a:r>
-                  <a:rPr sz="1200" b="0" i="0" u="none" strike="noStrike">
+                  <a:rPr lang="en-US" sz="1200" b="0" i="0" u="none" strike="noStrike">
                     <a:solidFill>
                       <a:srgbClr val="262626"/>
                     </a:solidFill>
@@ -1726,7 +1661,7 @@
     </p:spTree>
     <p:extLst>
       <p:ext uri="{BB962C8B-B14F-4D97-AF65-F5344CB8AC3E}">
-        <p14:creationId xmlns:p14="http://schemas.microsoft.com/office/powerpoint/2010/main" val="4170588210"/>
+        <p14:creationId xmlns:p14="http://schemas.microsoft.com/office/powerpoint/2010/main" val="326801250"/>
       </p:ext>
     </p:extLst>
   </p:cSld>
@@ -3323,6 +3258,90 @@
             <a:fld id="{F7021451-1387-4CA6-816F-3879F97B5CBC}" type="slidenum">
               <a:rPr lang="en-US"/>
               <a:t>25</a:t>
+            </a:fld>
+            <a:endParaRPr lang="en-US"/>
+          </a:p>
+        </p:txBody>
+      </p:sp>
+    </p:spTree>
+    <p:extLst>
+      <p:ext uri="{BB962C8B-B14F-4D97-AF65-F5344CB8AC3E}">
+        <p14:creationId xmlns:p14="http://schemas.microsoft.com/office/powerpoint/2010/main" val="1024086991"/>
+      </p:ext>
+    </p:extLst>
+  </p:cSld>
+  <p:clrMapOvr>
+    <a:masterClrMapping/>
+  </p:clrMapOvr>
+</p:notes>
+</file>
+
+<file path=ppt/notesSlides/notesSlide26.xml><?xml version="1.0" encoding="utf-8"?>
+<p:notes xmlns:a="http://schemas.openxmlformats.org/drawingml/2006/main" xmlns:r="http://schemas.openxmlformats.org/officeDocument/2006/relationships" xmlns:p="http://schemas.openxmlformats.org/presentationml/2006/main">
+  <p:cSld>
+    <p:spTree>
+      <p:nvGrpSpPr>
+        <p:cNvPr id="1" name=""/>
+        <p:cNvGrpSpPr/>
+        <p:nvPr/>
+      </p:nvGrpSpPr>
+      <p:grpSpPr>
+        <a:xfrm>
+          <a:off x="0" y="0"/>
+          <a:ext cx="0" cy="0"/>
+          <a:chOff x="0" y="0"/>
+          <a:chExt cx="0" cy="0"/>
+        </a:xfrm>
+      </p:grpSpPr>
+      <p:sp>
+        <p:nvSpPr>
+          <p:cNvPr id="2" name="Slide Image Placeholder 1"/>
+          <p:cNvSpPr>
+            <a:spLocks noGrp="1" noRot="1" noChangeAspect="1"/>
+          </p:cNvSpPr>
+          <p:nvPr>
+            <p:ph type="sldImg"/>
+          </p:nvPr>
+        </p:nvSpPr>
+        <p:spPr/>
+      </p:sp>
+      <p:sp>
+        <p:nvSpPr>
+          <p:cNvPr id="3" name="Notes Placeholder 2"/>
+          <p:cNvSpPr>
+            <a:spLocks noGrp="1"/>
+          </p:cNvSpPr>
+          <p:nvPr>
+            <p:ph type="body" idx="1"/>
+          </p:nvPr>
+        </p:nvSpPr>
+        <p:spPr/>
+        <p:txBody>
+          <a:bodyPr/>
+          <a:lstStyle/>
+          <a:p>
+            <a:endParaRPr lang="en-US" dirty="0"/>
+          </a:p>
+        </p:txBody>
+      </p:sp>
+      <p:sp>
+        <p:nvSpPr>
+          <p:cNvPr id="4" name="Slide Number Placeholder 3"/>
+          <p:cNvSpPr>
+            <a:spLocks noGrp="1"/>
+          </p:cNvSpPr>
+          <p:nvPr>
+            <p:ph type="sldNum" sz="quarter" idx="10"/>
+          </p:nvPr>
+        </p:nvSpPr>
+        <p:spPr/>
+        <p:txBody>
+          <a:bodyPr/>
+          <a:lstStyle/>
+          <a:p>
+            <a:fld id="{F7021451-1387-4CA6-816F-3879F97B5CBC}" type="slidenum">
+              <a:rPr lang="en-US"/>
+              <a:t>26</a:t>
             </a:fld>
             <a:endParaRPr lang="en-US"/>
           </a:p>
@@ -4700,7 +4719,7 @@
                   <a:schemeClr val="accent1"/>
                 </a:solidFill>
               </a:rPr>
-              <a:t>[Student Name 1]   -   [Roll No]</a:t>
+              <a:t>Mohammed Akmal K M   -   24B11AI262</a:t>
             </a:r>
             <a:endParaRPr lang="en-US" sz="1600" dirty="0"/>
           </a:p>
@@ -4717,7 +4736,7 @@
                   <a:schemeClr val="accent1"/>
                 </a:solidFill>
               </a:rPr>
-              <a:t>[Student Name 2]   -   [Roll No]</a:t>
+              <a:t>Ch. Vijay Kumar   -   24B11AI062</a:t>
             </a:r>
             <a:endParaRPr lang="en-US" sz="1600" dirty="0"/>
           </a:p>
@@ -4734,7 +4753,7 @@
                   <a:schemeClr val="accent1"/>
                 </a:solidFill>
               </a:rPr>
-              <a:t>[Student Name 3]   -   [Roll No]</a:t>
+              <a:t>D. Sri Sashank   -   24B11AI085</a:t>
             </a:r>
             <a:endParaRPr lang="en-US" sz="1600" dirty="0"/>
           </a:p>
@@ -4751,7 +4770,7 @@
                   <a:schemeClr val="accent1"/>
                 </a:solidFill>
               </a:rPr>
-              <a:t>[Student Name 4]   -   [Roll No]</a:t>
+              <a:t>G. Sai Sri Pavan   -   24B11AI139</a:t>
             </a:r>
             <a:endParaRPr lang="en-US" sz="1600" dirty="0"/>
           </a:p>
@@ -6901,7 +6920,7 @@
           </a:effectLst>
         </p:spPr>
         <p:txBody>
-          <a:bodyPr wrap="square" lIns="101600" tIns="152400" rIns="152400" bIns="76200" rtlCol="0" anchor="ctr"/>
+          <a:bodyPr wrap="square" lIns="101600" tIns="152400" rIns="152400" bIns="76200" rtlCol="0" anchor="t"/>
           <a:lstStyle/>
           <a:p>
             <a:pPr marL="0" indent="0" algn="l">
@@ -7122,7 +7141,7 @@
           </a:effectLst>
         </p:spPr>
         <p:txBody>
-          <a:bodyPr wrap="square" lIns="101600" tIns="152400" rIns="152400" bIns="76200" rtlCol="0" anchor="ctr"/>
+          <a:bodyPr wrap="square" lIns="101600" tIns="152400" rIns="152400" bIns="76200" rtlCol="0" anchor="t"/>
           <a:lstStyle/>
           <a:p>
             <a:pPr marL="0" indent="0" algn="l">
@@ -7215,66 +7234,62 @@
           </a:p>
         </p:txBody>
       </p:sp>
+      <p:pic>
+        <p:nvPicPr>
+          <p:cNvPr id="4" name="Screenshot distributions" descr="Histograms of the 8 features and the score"/>
+          <p:cNvPicPr>
+            <a:picLocks noChangeAspect="1"/>
+          </p:cNvPicPr>
+          <p:nvPr/>
+        </p:nvPicPr>
+        <p:blipFill>
+          <a:blip r:embed="rId3"/>
+          <a:stretch>
+            <a:fillRect/>
+          </a:stretch>
+        </p:blipFill>
+        <p:spPr>
+          <a:xfrm>
+            <a:off x="5050155" y="1554480"/>
+            <a:ext cx="6267450" cy="4297680"/>
+          </a:xfrm>
+          <a:prstGeom prst="rect">
+            <a:avLst/>
+          </a:prstGeom>
+        </p:spPr>
+      </p:pic>
       <p:sp>
         <p:nvSpPr>
-          <p:cNvPr id="4" name="Screenshot distributions"/>
+          <p:cNvPr id="5" name="Screenshot distributions frame"/>
           <p:cNvSpPr/>
           <p:nvPr/>
         </p:nvSpPr>
         <p:spPr>
           <a:xfrm>
-            <a:off x="5029200" y="1554480"/>
-            <a:ext cx="6309360" cy="4297680"/>
+            <a:off x="5050155" y="1554480"/>
+            <a:ext cx="6267450" cy="4297680"/>
           </a:xfrm>
           <a:prstGeom prst="rect">
             <a:avLst/>
           </a:prstGeom>
-          <a:solidFill>
-            <a:srgbClr val="F7F9FC"/>
-          </a:solidFill>
-          <a:ln w="19050">
+          <a:ln w="9525">
             <a:solidFill>
               <a:srgbClr val="9AA5B1"/>
             </a:solidFill>
-            <a:prstDash val="dash"/>
+            <a:prstDash val="solid"/>
           </a:ln>
         </p:spPr>
         <p:txBody>
-          <a:bodyPr wrap="square" lIns="101600" tIns="101600" rIns="101600" bIns="101600" rtlCol="0" anchor="ctr"/>
+          <a:bodyPr/>
           <a:lstStyle/>
           <a:p>
-            <a:pPr marL="0" indent="0" algn="ctr">
-              <a:buNone/>
-            </a:pPr>
-            <a:r>
-              <a:rPr lang="en-US" sz="1400" b="1" dirty="0">
-                <a:solidFill>
-                  <a:srgbClr val="7F7F7F"/>
-                </a:solidFill>
-              </a:rPr>
-              <a:t>SCREENSHOT</a:t>
-            </a:r>
-            <a:endParaRPr lang="en-US" sz="1400" dirty="0"/>
-          </a:p>
-          <a:p>
-            <a:pPr marL="0" indent="0" algn="ctr">
-              <a:buNone/>
-            </a:pPr>
-            <a:r>
-              <a:rPr lang="en-US" sz="1300" dirty="0">
-                <a:solidFill>
-                  <a:srgbClr val="7F7F7F"/>
-                </a:solidFill>
-              </a:rPr>
-              <a:t>Histograms of the 8 features and the score</a:t>
-            </a:r>
-            <a:endParaRPr lang="en-US" sz="1400" dirty="0"/>
+            <a:endParaRPr lang="en-US"/>
           </a:p>
         </p:txBody>
       </p:sp>
       <p:sp>
         <p:nvSpPr>
-          <p:cNvPr id="5" name="Screenshot distributions caption"/>
+          <p:cNvPr id="6" name="Screenshot distributions caption"/>
           <p:cNvSpPr txBox="1"/>
           <p:nvPr/>
         </p:nvSpPr>
@@ -7402,7 +7417,7 @@
           </a:effectLst>
         </p:spPr>
         <p:txBody>
-          <a:bodyPr wrap="square" lIns="101600" tIns="152400" rIns="152400" bIns="76200" rtlCol="0" anchor="ctr"/>
+          <a:bodyPr wrap="square" lIns="101600" tIns="152400" rIns="152400" bIns="76200" rtlCol="0" anchor="t"/>
           <a:lstStyle/>
           <a:p>
             <a:pPr marL="0" indent="0" algn="l">
@@ -7495,66 +7510,62 @@
           </a:p>
         </p:txBody>
       </p:sp>
+      <p:pic>
+        <p:nvPicPr>
+          <p:cNvPr id="4" name="Screenshot scatter" descr="Scatter plots of Performance_Score against each feature"/>
+          <p:cNvPicPr>
+            <a:picLocks noChangeAspect="1"/>
+          </p:cNvPicPr>
+          <p:nvPr/>
+        </p:nvPicPr>
+        <p:blipFill>
+          <a:blip r:embed="rId3"/>
+          <a:stretch>
+            <a:fillRect/>
+          </a:stretch>
+        </p:blipFill>
+        <p:spPr>
+          <a:xfrm>
+            <a:off x="5029200" y="2097301"/>
+            <a:ext cx="6309360" cy="3212038"/>
+          </a:xfrm>
+          <a:prstGeom prst="rect">
+            <a:avLst/>
+          </a:prstGeom>
+        </p:spPr>
+      </p:pic>
       <p:sp>
         <p:nvSpPr>
-          <p:cNvPr id="4" name="Screenshot scatter"/>
+          <p:cNvPr id="5" name="Screenshot scatter frame"/>
           <p:cNvSpPr/>
           <p:nvPr/>
         </p:nvSpPr>
         <p:spPr>
           <a:xfrm>
-            <a:off x="5029200" y="1554480"/>
-            <a:ext cx="6309360" cy="4297680"/>
+            <a:off x="5029200" y="2097301"/>
+            <a:ext cx="6309360" cy="3212038"/>
           </a:xfrm>
           <a:prstGeom prst="rect">
             <a:avLst/>
           </a:prstGeom>
-          <a:solidFill>
-            <a:srgbClr val="F7F9FC"/>
-          </a:solidFill>
-          <a:ln w="19050">
+          <a:ln w="9525">
             <a:solidFill>
               <a:srgbClr val="9AA5B1"/>
             </a:solidFill>
-            <a:prstDash val="dash"/>
+            <a:prstDash val="solid"/>
           </a:ln>
         </p:spPr>
         <p:txBody>
-          <a:bodyPr wrap="square" lIns="101600" tIns="101600" rIns="101600" bIns="101600" rtlCol="0" anchor="ctr"/>
+          <a:bodyPr/>
           <a:lstStyle/>
           <a:p>
-            <a:pPr marL="0" indent="0" algn="ctr">
-              <a:buNone/>
-            </a:pPr>
-            <a:r>
-              <a:rPr lang="en-US" sz="1400" b="1" dirty="0">
-                <a:solidFill>
-                  <a:srgbClr val="7F7F7F"/>
-                </a:solidFill>
-              </a:rPr>
-              <a:t>SCREENSHOT</a:t>
-            </a:r>
-            <a:endParaRPr lang="en-US" sz="1400" dirty="0"/>
-          </a:p>
-          <a:p>
-            <a:pPr marL="0" indent="0" algn="ctr">
-              <a:buNone/>
-            </a:pPr>
-            <a:r>
-              <a:rPr lang="en-US" sz="1300" dirty="0">
-                <a:solidFill>
-                  <a:srgbClr val="7F7F7F"/>
-                </a:solidFill>
-              </a:rPr>
-              <a:t>Scatter plots of Performance_Score against each feature</a:t>
-            </a:r>
-            <a:endParaRPr lang="en-US" sz="1400" dirty="0"/>
+            <a:endParaRPr lang="en-US"/>
           </a:p>
         </p:txBody>
       </p:sp>
       <p:sp>
         <p:nvSpPr>
-          <p:cNvPr id="5" name="Screenshot scatter caption"/>
+          <p:cNvPr id="6" name="Screenshot scatter caption"/>
           <p:cNvSpPr txBox="1"/>
           <p:nvPr/>
         </p:nvSpPr>
@@ -7682,7 +7693,7 @@
           </a:effectLst>
         </p:spPr>
         <p:txBody>
-          <a:bodyPr wrap="square" lIns="101600" tIns="152400" rIns="152400" bIns="76200" rtlCol="0" anchor="ctr"/>
+          <a:bodyPr wrap="square" lIns="101600" tIns="152400" rIns="152400" bIns="76200" rtlCol="0" anchor="t"/>
           <a:lstStyle/>
           <a:p>
             <a:pPr marL="0" indent="0" algn="l">
@@ -7775,66 +7786,62 @@
           </a:p>
         </p:txBody>
       </p:sp>
+      <p:pic>
+        <p:nvPicPr>
+          <p:cNvPr id="4" name="Screenshot heatmap" descr="Correlation heatmap of numeric features and the score"/>
+          <p:cNvPicPr>
+            <a:picLocks noChangeAspect="1"/>
+          </p:cNvPicPr>
+          <p:nvPr/>
+        </p:nvPicPr>
+        <p:blipFill>
+          <a:blip r:embed="rId3"/>
+          <a:stretch>
+            <a:fillRect/>
+          </a:stretch>
+        </p:blipFill>
+        <p:spPr>
+          <a:xfrm>
+            <a:off x="5430679" y="1554480"/>
+            <a:ext cx="5506403" cy="4297680"/>
+          </a:xfrm>
+          <a:prstGeom prst="rect">
+            <a:avLst/>
+          </a:prstGeom>
+        </p:spPr>
+      </p:pic>
       <p:sp>
         <p:nvSpPr>
-          <p:cNvPr id="4" name="Screenshot heatmap"/>
+          <p:cNvPr id="5" name="Screenshot heatmap frame"/>
           <p:cNvSpPr/>
           <p:nvPr/>
         </p:nvSpPr>
         <p:spPr>
           <a:xfrm>
-            <a:off x="5029200" y="1554480"/>
-            <a:ext cx="6309360" cy="4297680"/>
+            <a:off x="5430679" y="1554480"/>
+            <a:ext cx="5506403" cy="4297680"/>
           </a:xfrm>
           <a:prstGeom prst="rect">
             <a:avLst/>
           </a:prstGeom>
-          <a:solidFill>
-            <a:srgbClr val="F7F9FC"/>
-          </a:solidFill>
-          <a:ln w="19050">
+          <a:ln w="9525">
             <a:solidFill>
               <a:srgbClr val="9AA5B1"/>
             </a:solidFill>
-            <a:prstDash val="dash"/>
+            <a:prstDash val="solid"/>
           </a:ln>
         </p:spPr>
         <p:txBody>
-          <a:bodyPr wrap="square" lIns="101600" tIns="101600" rIns="101600" bIns="101600" rtlCol="0" anchor="ctr"/>
+          <a:bodyPr/>
           <a:lstStyle/>
           <a:p>
-            <a:pPr marL="0" indent="0" algn="ctr">
-              <a:buNone/>
-            </a:pPr>
-            <a:r>
-              <a:rPr lang="en-US" sz="1400" b="1" dirty="0">
-                <a:solidFill>
-                  <a:srgbClr val="7F7F7F"/>
-                </a:solidFill>
-              </a:rPr>
-              <a:t>SCREENSHOT</a:t>
-            </a:r>
-            <a:endParaRPr lang="en-US" sz="1400" dirty="0"/>
-          </a:p>
-          <a:p>
-            <a:pPr marL="0" indent="0" algn="ctr">
-              <a:buNone/>
-            </a:pPr>
-            <a:r>
-              <a:rPr lang="en-US" sz="1300" dirty="0">
-                <a:solidFill>
-                  <a:srgbClr val="7F7F7F"/>
-                </a:solidFill>
-              </a:rPr>
-              <a:t>Correlation heatmap of numeric features and the score</a:t>
-            </a:r>
-            <a:endParaRPr lang="en-US" sz="1400" dirty="0"/>
+            <a:endParaRPr lang="en-US"/>
           </a:p>
         </p:txBody>
       </p:sp>
       <p:sp>
         <p:nvSpPr>
-          <p:cNvPr id="5" name="Screenshot heatmap caption"/>
+          <p:cNvPr id="6" name="Screenshot heatmap caption"/>
           <p:cNvSpPr txBox="1"/>
           <p:nvPr/>
         </p:nvSpPr>
@@ -8206,7 +8213,7 @@
           </a:effectLst>
         </p:spPr>
         <p:txBody>
-          <a:bodyPr wrap="square" lIns="101600" tIns="152400" rIns="152400" bIns="76200" rtlCol="0" anchor="ctr"/>
+          <a:bodyPr wrap="square" lIns="101600" tIns="152400" rIns="152400" bIns="76200" rtlCol="0" anchor="t"/>
           <a:lstStyle/>
           <a:p>
             <a:pPr marL="0" indent="0" algn="l">
@@ -8281,66 +8288,62 @@
           </a:p>
         </p:txBody>
       </p:sp>
+      <p:pic>
+        <p:nvPicPr>
+          <p:cNvPr id="8" name="Screenshot training console" descr="Terminal output of python src/train.py (training section)"/>
+          <p:cNvPicPr>
+            <a:picLocks noChangeAspect="1"/>
+          </p:cNvPicPr>
+          <p:nvPr/>
+        </p:nvPicPr>
+        <p:blipFill>
+          <a:blip r:embed="rId3"/>
+          <a:stretch>
+            <a:fillRect/>
+          </a:stretch>
+        </p:blipFill>
+        <p:spPr>
+          <a:xfrm>
+            <a:off x="6183223" y="3063240"/>
+            <a:ext cx="4659682" cy="2834640"/>
+          </a:xfrm>
+          <a:prstGeom prst="rect">
+            <a:avLst/>
+          </a:prstGeom>
+        </p:spPr>
+      </p:pic>
       <p:sp>
         <p:nvSpPr>
-          <p:cNvPr id="8" name="Screenshot training console"/>
+          <p:cNvPr id="9" name="Screenshot training console frame"/>
           <p:cNvSpPr/>
           <p:nvPr/>
         </p:nvSpPr>
         <p:spPr>
           <a:xfrm>
-            <a:off x="5669280" y="3063240"/>
-            <a:ext cx="5687568" cy="2834640"/>
+            <a:off x="6183223" y="3063240"/>
+            <a:ext cx="4659682" cy="2834640"/>
           </a:xfrm>
           <a:prstGeom prst="rect">
             <a:avLst/>
           </a:prstGeom>
-          <a:solidFill>
-            <a:srgbClr val="F7F9FC"/>
-          </a:solidFill>
-          <a:ln w="19050">
+          <a:ln w="9525">
             <a:solidFill>
               <a:srgbClr val="9AA5B1"/>
             </a:solidFill>
-            <a:prstDash val="dash"/>
+            <a:prstDash val="solid"/>
           </a:ln>
         </p:spPr>
         <p:txBody>
-          <a:bodyPr wrap="square" lIns="101600" tIns="101600" rIns="101600" bIns="101600" rtlCol="0" anchor="ctr"/>
+          <a:bodyPr/>
           <a:lstStyle/>
           <a:p>
-            <a:pPr marL="0" indent="0" algn="ctr">
-              <a:buNone/>
-            </a:pPr>
-            <a:r>
-              <a:rPr lang="en-US" sz="1400" b="1" dirty="0">
-                <a:solidFill>
-                  <a:srgbClr val="7F7F7F"/>
-                </a:solidFill>
-              </a:rPr>
-              <a:t>SCREENSHOT</a:t>
-            </a:r>
-            <a:endParaRPr lang="en-US" sz="1400" dirty="0"/>
-          </a:p>
-          <a:p>
-            <a:pPr marL="0" indent="0" algn="ctr">
-              <a:buNone/>
-            </a:pPr>
-            <a:r>
-              <a:rPr lang="en-US" sz="1300" dirty="0">
-                <a:solidFill>
-                  <a:srgbClr val="7F7F7F"/>
-                </a:solidFill>
-              </a:rPr>
-              <a:t>Terminal output of python src/train.py (training section)</a:t>
-            </a:r>
-            <a:endParaRPr lang="en-US" sz="1400" dirty="0"/>
+            <a:endParaRPr lang="en-US"/>
           </a:p>
         </p:txBody>
       </p:sp>
       <p:sp>
         <p:nvSpPr>
-          <p:cNvPr id="9" name="Screenshot training console caption"/>
+          <p:cNvPr id="10" name="Screenshot training console caption"/>
           <p:cNvSpPr txBox="1"/>
           <p:nvPr/>
         </p:nvSpPr>
@@ -8455,7 +8458,7 @@
         </p:nvGraphicFramePr>
         <p:xfrm>
           <a:off x="841248" y="1554480"/>
-          <a:ext cx="10515600" cy="4206240"/>
+          <a:ext cx="10515600" cy="914400"/>
         </p:xfrm>
         <a:graphic>
           <a:graphicData uri="http://schemas.openxmlformats.org/drawingml/2006/table">
@@ -12239,6 +12242,42 @@
           </a:graphicData>
         </a:graphic>
       </p:graphicFrame>
+      <p:sp>
+        <p:nvSpPr>
+          <p:cNvPr id="4" name="Table note"/>
+          <p:cNvSpPr txBox="1"/>
+          <p:nvPr/>
+        </p:nvSpPr>
+        <p:spPr>
+          <a:xfrm>
+            <a:off x="841248" y="5897880"/>
+            <a:ext cx="10515600" cy="320040"/>
+          </a:xfrm>
+          <a:prstGeom prst="rect">
+            <a:avLst/>
+          </a:prstGeom>
+          <a:noFill/>
+          <a:ln/>
+        </p:spPr>
+        <p:txBody>
+          <a:bodyPr wrap="square" lIns="0" tIns="0" rIns="0" bIns="0" rtlCol="0" anchor="ctr"/>
+          <a:lstStyle/>
+          <a:p>
+            <a:pPr marL="0" indent="0">
+              <a:buNone/>
+            </a:pPr>
+            <a:r>
+              <a:rPr lang="en-US" sz="1300" dirty="0">
+                <a:solidFill>
+                  <a:srgbClr val="7F7F7F"/>
+                </a:solidFill>
+              </a:rPr>
+              <a:t>Sorted by CV RMSE. Highlighted row = the deployed model.</a:t>
+            </a:r>
+            <a:endParaRPr lang="en-US" sz="1300" dirty="0"/>
+          </a:p>
+        </p:txBody>
+      </p:sp>
     </p:spTree>
   </p:cSld>
   <p:clrMapOvr>
@@ -12333,7 +12372,7 @@
           </a:effectLst>
         </p:spPr>
         <p:txBody>
-          <a:bodyPr wrap="square" lIns="101600" tIns="152400" rIns="152400" bIns="76200" rtlCol="0" anchor="ctr"/>
+          <a:bodyPr wrap="square" lIns="101600" tIns="152400" rIns="152400" bIns="76200" rtlCol="0" anchor="t"/>
           <a:lstStyle/>
           <a:p>
             <a:pPr marL="0" indent="0" algn="l">
@@ -12798,7 +12837,7 @@
           </a:effectLst>
         </p:spPr>
         <p:txBody>
-          <a:bodyPr wrap="square" lIns="101600" tIns="152400" rIns="152400" bIns="76200" rtlCol="0" anchor="ctr"/>
+          <a:bodyPr wrap="square" lIns="101600" tIns="152400" rIns="152400" bIns="76200" rtlCol="0" anchor="t"/>
           <a:lstStyle/>
           <a:p>
             <a:pPr marL="0" indent="0" algn="l">
@@ -12873,66 +12912,62 @@
           </a:p>
         </p:txBody>
       </p:sp>
+      <p:pic>
+        <p:nvPicPr>
+          <p:cNvPr id="8" name="Screenshot actual vs predicted" descr="Actual vs predicted scatter on the test set (actual_vs_predicted.png)"/>
+          <p:cNvPicPr>
+            <a:picLocks noChangeAspect="1"/>
+          </p:cNvPicPr>
+          <p:nvPr/>
+        </p:nvPicPr>
+        <p:blipFill>
+          <a:blip r:embed="rId3"/>
+          <a:stretch>
+            <a:fillRect/>
+          </a:stretch>
+        </p:blipFill>
+        <p:spPr>
+          <a:xfrm>
+            <a:off x="7255764" y="3017520"/>
+            <a:ext cx="2880360" cy="2880360"/>
+          </a:xfrm>
+          <a:prstGeom prst="rect">
+            <a:avLst/>
+          </a:prstGeom>
+        </p:spPr>
+      </p:pic>
       <p:sp>
         <p:nvSpPr>
-          <p:cNvPr id="8" name="Screenshot actual vs predicted"/>
+          <p:cNvPr id="9" name="Screenshot actual vs predicted frame"/>
           <p:cNvSpPr/>
           <p:nvPr/>
         </p:nvSpPr>
         <p:spPr>
           <a:xfrm>
-            <a:off x="6035040" y="3017520"/>
-            <a:ext cx="5321808" cy="2880360"/>
+            <a:off x="7255764" y="3017520"/>
+            <a:ext cx="2880360" cy="2880360"/>
           </a:xfrm>
           <a:prstGeom prst="rect">
             <a:avLst/>
           </a:prstGeom>
-          <a:solidFill>
-            <a:srgbClr val="F7F9FC"/>
-          </a:solidFill>
-          <a:ln w="19050">
+          <a:ln w="9525">
             <a:solidFill>
               <a:srgbClr val="9AA5B1"/>
             </a:solidFill>
-            <a:prstDash val="dash"/>
+            <a:prstDash val="solid"/>
           </a:ln>
         </p:spPr>
         <p:txBody>
-          <a:bodyPr wrap="square" lIns="101600" tIns="101600" rIns="101600" bIns="101600" rtlCol="0" anchor="ctr"/>
+          <a:bodyPr/>
           <a:lstStyle/>
           <a:p>
-            <a:pPr marL="0" indent="0" algn="ctr">
-              <a:buNone/>
-            </a:pPr>
-            <a:r>
-              <a:rPr lang="en-US" sz="1400" b="1" dirty="0">
-                <a:solidFill>
-                  <a:srgbClr val="7F7F7F"/>
-                </a:solidFill>
-              </a:rPr>
-              <a:t>SCREENSHOT</a:t>
-            </a:r>
-            <a:endParaRPr lang="en-US" sz="1400" dirty="0"/>
-          </a:p>
-          <a:p>
-            <a:pPr marL="0" indent="0" algn="ctr">
-              <a:buNone/>
-            </a:pPr>
-            <a:r>
-              <a:rPr lang="en-US" sz="1300" dirty="0">
-                <a:solidFill>
-                  <a:srgbClr val="7F7F7F"/>
-                </a:solidFill>
-              </a:rPr>
-              <a:t>Actual vs predicted scatter on the test set (actual_vs_predicted.png)</a:t>
-            </a:r>
-            <a:endParaRPr lang="en-US" sz="1400" dirty="0"/>
+            <a:endParaRPr lang="en-US"/>
           </a:p>
         </p:txBody>
       </p:sp>
       <p:sp>
         <p:nvSpPr>
-          <p:cNvPr id="9" name="Screenshot actual vs predicted caption"/>
+          <p:cNvPr id="10" name="Screenshot actual vs predicted caption"/>
           <p:cNvSpPr txBox="1"/>
           <p:nvPr/>
         </p:nvSpPr>
@@ -13153,66 +13188,62 @@
           </a:p>
         </p:txBody>
       </p:sp>
+      <p:pic>
+        <p:nvPicPr>
+          <p:cNvPr id="4" name="Screenshot importance" descr="Permutation importance bar chart (feature_importance.png)"/>
+          <p:cNvPicPr>
+            <a:picLocks noChangeAspect="1"/>
+          </p:cNvPicPr>
+          <p:nvPr/>
+        </p:nvPicPr>
+        <p:blipFill>
+          <a:blip r:embed="rId3"/>
+          <a:stretch>
+            <a:fillRect/>
+          </a:stretch>
+        </p:blipFill>
+        <p:spPr>
+          <a:xfrm>
+            <a:off x="5486400" y="1822269"/>
+            <a:ext cx="5852160" cy="3762103"/>
+          </a:xfrm>
+          <a:prstGeom prst="rect">
+            <a:avLst/>
+          </a:prstGeom>
+        </p:spPr>
+      </p:pic>
       <p:sp>
         <p:nvSpPr>
-          <p:cNvPr id="4" name="Screenshot importance"/>
+          <p:cNvPr id="5" name="Screenshot importance frame"/>
           <p:cNvSpPr/>
           <p:nvPr/>
         </p:nvSpPr>
         <p:spPr>
           <a:xfrm>
-            <a:off x="5486400" y="1554480"/>
-            <a:ext cx="5852160" cy="4297680"/>
+            <a:off x="5486400" y="1822269"/>
+            <a:ext cx="5852160" cy="3762103"/>
           </a:xfrm>
           <a:prstGeom prst="rect">
             <a:avLst/>
           </a:prstGeom>
-          <a:solidFill>
-            <a:srgbClr val="F7F9FC"/>
-          </a:solidFill>
-          <a:ln w="19050">
+          <a:ln w="9525">
             <a:solidFill>
               <a:srgbClr val="9AA5B1"/>
             </a:solidFill>
-            <a:prstDash val="dash"/>
+            <a:prstDash val="solid"/>
           </a:ln>
         </p:spPr>
         <p:txBody>
-          <a:bodyPr wrap="square" lIns="101600" tIns="101600" rIns="101600" bIns="101600" rtlCol="0" anchor="ctr"/>
+          <a:bodyPr/>
           <a:lstStyle/>
           <a:p>
-            <a:pPr marL="0" indent="0" algn="ctr">
-              <a:buNone/>
-            </a:pPr>
-            <a:r>
-              <a:rPr lang="en-US" sz="1400" b="1" dirty="0">
-                <a:solidFill>
-                  <a:srgbClr val="7F7F7F"/>
-                </a:solidFill>
-              </a:rPr>
-              <a:t>SCREENSHOT</a:t>
-            </a:r>
-            <a:endParaRPr lang="en-US" sz="1400" dirty="0"/>
-          </a:p>
-          <a:p>
-            <a:pPr marL="0" indent="0" algn="ctr">
-              <a:buNone/>
-            </a:pPr>
-            <a:r>
-              <a:rPr lang="en-US" sz="1300" dirty="0">
-                <a:solidFill>
-                  <a:srgbClr val="7F7F7F"/>
-                </a:solidFill>
-              </a:rPr>
-              <a:t>Permutation importance bar chart (feature_importance.png)</a:t>
-            </a:r>
-            <a:endParaRPr lang="en-US" sz="1400" dirty="0"/>
+            <a:endParaRPr lang="en-US"/>
           </a:p>
         </p:txBody>
       </p:sp>
       <p:sp>
         <p:nvSpPr>
-          <p:cNvPr id="5" name="Screenshot importance caption"/>
+          <p:cNvPr id="6" name="Screenshot importance caption"/>
           <p:cNvSpPr txBox="1"/>
           <p:nvPr/>
         </p:nvSpPr>
@@ -13340,7 +13371,7 @@
           </a:effectLst>
         </p:spPr>
         <p:txBody>
-          <a:bodyPr wrap="square" lIns="101600" tIns="152400" rIns="152400" bIns="76200" rtlCol="0" anchor="ctr"/>
+          <a:bodyPr wrap="square" lIns="101600" tIns="152400" rIns="152400" bIns="76200" rtlCol="0" anchor="t"/>
           <a:lstStyle/>
           <a:p>
             <a:pPr marL="0" indent="0" algn="l">
@@ -13480,7 +13511,7 @@
           </a:effectLst>
         </p:spPr>
         <p:txBody>
-          <a:bodyPr wrap="square" lIns="101600" tIns="152400" rIns="152400" bIns="76200" rtlCol="0" anchor="ctr"/>
+          <a:bodyPr wrap="square" lIns="101600" tIns="152400" rIns="152400" bIns="76200" rtlCol="0" anchor="t"/>
           <a:lstStyle/>
           <a:p>
             <a:pPr marL="0" indent="0" algn="l">
@@ -13701,7 +13732,7 @@
           </a:effectLst>
         </p:spPr>
         <p:txBody>
-          <a:bodyPr wrap="square" lIns="101600" tIns="152400" rIns="152400" bIns="76200" rtlCol="0" anchor="ctr"/>
+          <a:bodyPr wrap="square" lIns="101600" tIns="152400" rIns="152400" bIns="76200" rtlCol="0" anchor="t"/>
           <a:lstStyle/>
           <a:p>
             <a:pPr marL="0" indent="0" algn="l">
@@ -13886,7 +13917,7 @@
           </a:effectLst>
         </p:spPr>
         <p:txBody>
-          <a:bodyPr wrap="square" lIns="101600" tIns="152400" rIns="152400" bIns="76200" rtlCol="0" anchor="ctr"/>
+          <a:bodyPr wrap="square" lIns="101600" tIns="152400" rIns="152400" bIns="76200" rtlCol="0" anchor="t"/>
           <a:lstStyle/>
           <a:p>
             <a:pPr marL="0" indent="0" algn="l">
@@ -14034,12 +14065,12 @@
         </p:nvSpPr>
         <p:spPr>
           <a:xfrm>
-            <a:off x="841248" y="1508760"/>
-            <a:ext cx="2377440" cy="1143000"/>
+            <a:off x="841248" y="1417320"/>
+            <a:ext cx="2377440" cy="914400"/>
           </a:xfrm>
           <a:prstGeom prst="roundRect">
             <a:avLst>
-              <a:gd name="adj" fmla="val 9600"/>
+              <a:gd name="adj" fmla="val 12000"/>
             </a:avLst>
           </a:prstGeom>
           <a:solidFill>
@@ -14095,7 +14126,7 @@
         </p:nvSpPr>
         <p:spPr>
           <a:xfrm>
-            <a:off x="3236976" y="2075688"/>
+            <a:off x="3236976" y="1874520"/>
             <a:ext cx="283464" cy="0"/>
           </a:xfrm>
           <a:prstGeom prst="line">
@@ -14110,6 +14141,13 @@
             <a:tailEnd type="triangle"/>
           </a:ln>
         </p:spPr>
+        <p:txBody>
+          <a:bodyPr/>
+          <a:lstStyle/>
+          <a:p>
+            <a:endParaRPr lang="en-US"/>
+          </a:p>
+        </p:txBody>
       </p:sp>
       <p:sp>
         <p:nvSpPr>
@@ -14119,12 +14157,12 @@
         </p:nvSpPr>
         <p:spPr>
           <a:xfrm>
-            <a:off x="3538728" y="1508760"/>
-            <a:ext cx="2377440" cy="1143000"/>
+            <a:off x="3538728" y="1417320"/>
+            <a:ext cx="2377440" cy="914400"/>
           </a:xfrm>
           <a:prstGeom prst="roundRect">
             <a:avLst>
-              <a:gd name="adj" fmla="val 9600"/>
+              <a:gd name="adj" fmla="val 12000"/>
             </a:avLst>
           </a:prstGeom>
           <a:solidFill>
@@ -14180,7 +14218,7 @@
         </p:nvSpPr>
         <p:spPr>
           <a:xfrm>
-            <a:off x="5934456" y="2075688"/>
+            <a:off x="5934456" y="1874520"/>
             <a:ext cx="283464" cy="0"/>
           </a:xfrm>
           <a:prstGeom prst="line">
@@ -14195,6 +14233,13 @@
             <a:tailEnd type="triangle"/>
           </a:ln>
         </p:spPr>
+        <p:txBody>
+          <a:bodyPr/>
+          <a:lstStyle/>
+          <a:p>
+            <a:endParaRPr lang="en-US"/>
+          </a:p>
+        </p:txBody>
       </p:sp>
       <p:sp>
         <p:nvSpPr>
@@ -14204,12 +14249,12 @@
         </p:nvSpPr>
         <p:spPr>
           <a:xfrm>
-            <a:off x="6236208" y="1508760"/>
-            <a:ext cx="2377440" cy="1143000"/>
+            <a:off x="6236208" y="1417320"/>
+            <a:ext cx="2377440" cy="914400"/>
           </a:xfrm>
           <a:prstGeom prst="roundRect">
             <a:avLst>
-              <a:gd name="adj" fmla="val 9600"/>
+              <a:gd name="adj" fmla="val 12000"/>
             </a:avLst>
           </a:prstGeom>
           <a:solidFill>
@@ -14265,7 +14310,7 @@
         </p:nvSpPr>
         <p:spPr>
           <a:xfrm>
-            <a:off x="8631936" y="2075688"/>
+            <a:off x="8631936" y="1874520"/>
             <a:ext cx="283464" cy="0"/>
           </a:xfrm>
           <a:prstGeom prst="line">
@@ -14280,6 +14325,13 @@
             <a:tailEnd type="triangle"/>
           </a:ln>
         </p:spPr>
+        <p:txBody>
+          <a:bodyPr/>
+          <a:lstStyle/>
+          <a:p>
+            <a:endParaRPr lang="en-US"/>
+          </a:p>
+        </p:txBody>
       </p:sp>
       <p:sp>
         <p:nvSpPr>
@@ -14289,12 +14341,12 @@
         </p:nvSpPr>
         <p:spPr>
           <a:xfrm>
-            <a:off x="8933688" y="1508760"/>
-            <a:ext cx="2377440" cy="1143000"/>
+            <a:off x="8933688" y="1417320"/>
+            <a:ext cx="2377440" cy="914400"/>
           </a:xfrm>
           <a:prstGeom prst="roundRect">
             <a:avLst>
-              <a:gd name="adj" fmla="val 9600"/>
+              <a:gd name="adj" fmla="val 12000"/>
             </a:avLst>
           </a:prstGeom>
           <a:solidFill>
@@ -14344,292 +14396,13 @@
       </p:sp>
       <p:sp>
         <p:nvSpPr>
-          <p:cNvPr id="10" name="Screenshot app builder"/>
-          <p:cNvSpPr/>
-          <p:nvPr/>
-        </p:nvSpPr>
-        <p:spPr>
-          <a:xfrm>
-            <a:off x="841248" y="2880360"/>
-            <a:ext cx="3383280" cy="2926080"/>
-          </a:xfrm>
-          <a:prstGeom prst="rect">
-            <a:avLst/>
-          </a:prstGeom>
-          <a:solidFill>
-            <a:srgbClr val="F7F9FC"/>
-          </a:solidFill>
-          <a:ln w="19050">
-            <a:solidFill>
-              <a:srgbClr val="9AA5B1"/>
-            </a:solidFill>
-            <a:prstDash val="dash"/>
-          </a:ln>
-        </p:spPr>
-        <p:txBody>
-          <a:bodyPr wrap="square" lIns="101600" tIns="101600" rIns="101600" bIns="101600" rtlCol="0" anchor="ctr"/>
-          <a:lstStyle/>
-          <a:p>
-            <a:pPr marL="0" indent="0" algn="ctr">
-              <a:buNone/>
-            </a:pPr>
-            <a:r>
-              <a:rPr lang="en-US" sz="1400" b="1" dirty="0">
-                <a:solidFill>
-                  <a:srgbClr val="7F7F7F"/>
-                </a:solidFill>
-              </a:rPr>
-              <a:t>SCREENSHOT</a:t>
-            </a:r>
-            <a:endParaRPr lang="en-US" sz="1400" dirty="0"/>
-          </a:p>
-          <a:p>
-            <a:pPr marL="0" indent="0" algn="ctr">
-              <a:buNone/>
-            </a:pPr>
-            <a:r>
-              <a:rPr lang="en-US" sz="1300" dirty="0">
-                <a:solidFill>
-                  <a:srgbClr val="7F7F7F"/>
-                </a:solidFill>
-              </a:rPr>
-              <a:t>Streamlit PC builder with parts selected</a:t>
-            </a:r>
-            <a:endParaRPr lang="en-US" sz="1400" dirty="0"/>
-          </a:p>
-        </p:txBody>
-      </p:sp>
-      <p:sp>
-        <p:nvSpPr>
-          <p:cNvPr id="11" name="Screenshot app builder caption"/>
+          <p:cNvPr id="10" name="App note"/>
           <p:cNvSpPr txBox="1"/>
           <p:nvPr/>
         </p:nvSpPr>
         <p:spPr>
           <a:xfrm>
-            <a:off x="841248" y="5852160"/>
-            <a:ext cx="3383280" cy="292608"/>
-          </a:xfrm>
-          <a:prstGeom prst="rect">
-            <a:avLst/>
-          </a:prstGeom>
-          <a:noFill/>
-          <a:ln/>
-        </p:spPr>
-        <p:txBody>
-          <a:bodyPr wrap="square" lIns="0" tIns="0" rIns="0" bIns="0" rtlCol="0" anchor="t"/>
-          <a:lstStyle/>
-          <a:p>
-            <a:pPr marL="0" indent="0" algn="l">
-              <a:buNone/>
-            </a:pPr>
-            <a:r>
-              <a:rPr lang="en-US" sz="1300" dirty="0">
-                <a:solidFill>
-                  <a:srgbClr val="7F7F7F"/>
-                </a:solidFill>
-              </a:rPr>
-              <a:t>Part-by-part builder</a:t>
-            </a:r>
-            <a:endParaRPr lang="en-US" sz="1300" dirty="0"/>
-          </a:p>
-        </p:txBody>
-      </p:sp>
-      <p:sp>
-        <p:nvSpPr>
-          <p:cNvPr id="12" name="Screenshot app score"/>
-          <p:cNvSpPr/>
-          <p:nvPr/>
-        </p:nvSpPr>
-        <p:spPr>
-          <a:xfrm>
-            <a:off x="4407408" y="2880360"/>
-            <a:ext cx="3383280" cy="2926080"/>
-          </a:xfrm>
-          <a:prstGeom prst="rect">
-            <a:avLst/>
-          </a:prstGeom>
-          <a:solidFill>
-            <a:srgbClr val="F7F9FC"/>
-          </a:solidFill>
-          <a:ln w="19050">
-            <a:solidFill>
-              <a:srgbClr val="9AA5B1"/>
-            </a:solidFill>
-            <a:prstDash val="dash"/>
-          </a:ln>
-        </p:spPr>
-        <p:txBody>
-          <a:bodyPr wrap="square" lIns="101600" tIns="101600" rIns="101600" bIns="101600" rtlCol="0" anchor="ctr"/>
-          <a:lstStyle/>
-          <a:p>
-            <a:pPr marL="0" indent="0" algn="ctr">
-              <a:buNone/>
-            </a:pPr>
-            <a:r>
-              <a:rPr lang="en-US" sz="1400" b="1" dirty="0">
-                <a:solidFill>
-                  <a:srgbClr val="7F7F7F"/>
-                </a:solidFill>
-              </a:rPr>
-              <a:t>SCREENSHOT</a:t>
-            </a:r>
-            <a:endParaRPr lang="en-US" sz="1400" dirty="0"/>
-          </a:p>
-          <a:p>
-            <a:pPr marL="0" indent="0" algn="ctr">
-              <a:buNone/>
-            </a:pPr>
-            <a:r>
-              <a:rPr lang="en-US" sz="1300" dirty="0">
-                <a:solidFill>
-                  <a:srgbClr val="7F7F7F"/>
-                </a:solidFill>
-              </a:rPr>
-              <a:t>Performance Score panel and sidebar metrics (R², MAE, RMSE)</a:t>
-            </a:r>
-            <a:endParaRPr lang="en-US" sz="1400" dirty="0"/>
-          </a:p>
-        </p:txBody>
-      </p:sp>
-      <p:sp>
-        <p:nvSpPr>
-          <p:cNvPr id="13" name="Screenshot app score caption"/>
-          <p:cNvSpPr txBox="1"/>
-          <p:nvPr/>
-        </p:nvSpPr>
-        <p:spPr>
-          <a:xfrm>
-            <a:off x="4407408" y="5852160"/>
-            <a:ext cx="3383280" cy="292608"/>
-          </a:xfrm>
-          <a:prstGeom prst="rect">
-            <a:avLst/>
-          </a:prstGeom>
-          <a:noFill/>
-          <a:ln/>
-        </p:spPr>
-        <p:txBody>
-          <a:bodyPr wrap="square" lIns="0" tIns="0" rIns="0" bIns="0" rtlCol="0" anchor="t"/>
-          <a:lstStyle/>
-          <a:p>
-            <a:pPr marL="0" indent="0" algn="l">
-              <a:buNone/>
-            </a:pPr>
-            <a:r>
-              <a:rPr lang="en-US" sz="1300" dirty="0">
-                <a:solidFill>
-                  <a:srgbClr val="7F7F7F"/>
-                </a:solidFill>
-              </a:rPr>
-              <a:t>Live score and model metrics</a:t>
-            </a:r>
-            <a:endParaRPr lang="en-US" sz="1300" dirty="0"/>
-          </a:p>
-        </p:txBody>
-      </p:sp>
-      <p:sp>
-        <p:nvSpPr>
-          <p:cNvPr id="14" name="Screenshot app inputs"/>
-          <p:cNvSpPr/>
-          <p:nvPr/>
-        </p:nvSpPr>
-        <p:spPr>
-          <a:xfrm>
-            <a:off x="7973568" y="2880360"/>
-            <a:ext cx="3383280" cy="2926080"/>
-          </a:xfrm>
-          <a:prstGeom prst="rect">
-            <a:avLst/>
-          </a:prstGeom>
-          <a:solidFill>
-            <a:srgbClr val="F7F9FC"/>
-          </a:solidFill>
-          <a:ln w="19050">
-            <a:solidFill>
-              <a:srgbClr val="9AA5B1"/>
-            </a:solidFill>
-            <a:prstDash val="dash"/>
-          </a:ln>
-        </p:spPr>
-        <p:txBody>
-          <a:bodyPr wrap="square" lIns="101600" tIns="101600" rIns="101600" bIns="101600" rtlCol="0" anchor="ctr"/>
-          <a:lstStyle/>
-          <a:p>
-            <a:pPr marL="0" indent="0" algn="ctr">
-              <a:buNone/>
-            </a:pPr>
-            <a:r>
-              <a:rPr lang="en-US" sz="1400" b="1" dirty="0">
-                <a:solidFill>
-                  <a:srgbClr val="7F7F7F"/>
-                </a:solidFill>
-              </a:rPr>
-              <a:t>SCREENSHOT</a:t>
-            </a:r>
-            <a:endParaRPr lang="en-US" sz="1400" dirty="0"/>
-          </a:p>
-          <a:p>
-            <a:pPr marL="0" indent="0" algn="ctr">
-              <a:buNone/>
-            </a:pPr>
-            <a:r>
-              <a:rPr lang="en-US" sz="1300" dirty="0">
-                <a:solidFill>
-                  <a:srgbClr val="7F7F7F"/>
-                </a:solidFill>
-              </a:rPr>
-              <a:t>“What the model sees” tab</a:t>
-            </a:r>
-            <a:endParaRPr lang="en-US" sz="1400" dirty="0"/>
-          </a:p>
-        </p:txBody>
-      </p:sp>
-      <p:sp>
-        <p:nvSpPr>
-          <p:cNvPr id="15" name="Screenshot app inputs caption"/>
-          <p:cNvSpPr txBox="1"/>
-          <p:nvPr/>
-        </p:nvSpPr>
-        <p:spPr>
-          <a:xfrm>
-            <a:off x="7973568" y="5852160"/>
-            <a:ext cx="3383280" cy="292608"/>
-          </a:xfrm>
-          <a:prstGeom prst="rect">
-            <a:avLst/>
-          </a:prstGeom>
-          <a:noFill/>
-          <a:ln/>
-        </p:spPr>
-        <p:txBody>
-          <a:bodyPr wrap="square" lIns="0" tIns="0" rIns="0" bIns="0" rtlCol="0" anchor="t"/>
-          <a:lstStyle/>
-          <a:p>
-            <a:pPr marL="0" indent="0" algn="l">
-              <a:buNone/>
-            </a:pPr>
-            <a:r>
-              <a:rPr lang="en-US" sz="1300" dirty="0">
-                <a:solidFill>
-                  <a:srgbClr val="7F7F7F"/>
-                </a:solidFill>
-              </a:rPr>
-              <a:t>The 8 model inputs</a:t>
-            </a:r>
-            <a:endParaRPr lang="en-US" sz="1300" dirty="0"/>
-          </a:p>
-        </p:txBody>
-      </p:sp>
-      <p:sp>
-        <p:nvSpPr>
-          <p:cNvPr id="16" name="App note"/>
-          <p:cNvSpPr txBox="1"/>
-          <p:nvPr/>
-        </p:nvSpPr>
-        <p:spPr>
-          <a:xfrm>
-            <a:off x="841248" y="6172200"/>
+            <a:off x="841248" y="2468880"/>
             <a:ext cx="10515600" cy="320040"/>
           </a:xfrm>
           <a:prstGeom prst="rect">
@@ -14646,12 +14419,190 @@
               <a:buNone/>
             </a:pPr>
             <a:r>
-              <a:rPr lang="en-US" sz="1300" b="1" dirty="0">
+              <a:rPr lang="en-US" sz="1400" b="1" dirty="0">
                 <a:solidFill>
                   <a:schemeClr val="accent2"/>
                 </a:solidFill>
               </a:rPr>
               <a:t>One model is used for every prediction: Linear Regression, loaded from performance_model.joblib.</a:t>
+            </a:r>
+            <a:endParaRPr lang="en-US" sz="1400" dirty="0"/>
+          </a:p>
+        </p:txBody>
+      </p:sp>
+      <p:pic>
+        <p:nvPicPr>
+          <p:cNvPr id="11" name="Screenshot app builder" descr="Streamlit PC builder with parts selected"/>
+          <p:cNvPicPr>
+            <a:picLocks noChangeAspect="1"/>
+          </p:cNvPicPr>
+          <p:nvPr/>
+        </p:nvPicPr>
+        <p:blipFill>
+          <a:blip r:embed="rId3"/>
+          <a:stretch>
+            <a:fillRect/>
+          </a:stretch>
+        </p:blipFill>
+        <p:spPr>
+          <a:xfrm>
+            <a:off x="1652778" y="2926080"/>
+            <a:ext cx="3497580" cy="3291840"/>
+          </a:xfrm>
+          <a:prstGeom prst="rect">
+            <a:avLst/>
+          </a:prstGeom>
+        </p:spPr>
+      </p:pic>
+      <p:sp>
+        <p:nvSpPr>
+          <p:cNvPr id="12" name="Screenshot app builder frame"/>
+          <p:cNvSpPr/>
+          <p:nvPr/>
+        </p:nvSpPr>
+        <p:spPr>
+          <a:xfrm>
+            <a:off x="1652778" y="2926080"/>
+            <a:ext cx="3497580" cy="3291840"/>
+          </a:xfrm>
+          <a:prstGeom prst="rect">
+            <a:avLst/>
+          </a:prstGeom>
+          <a:ln w="9525">
+            <a:solidFill>
+              <a:srgbClr val="9AA5B1"/>
+            </a:solidFill>
+            <a:prstDash val="solid"/>
+          </a:ln>
+        </p:spPr>
+        <p:txBody>
+          <a:bodyPr/>
+          <a:lstStyle/>
+          <a:p>
+            <a:endParaRPr lang="en-US"/>
+          </a:p>
+        </p:txBody>
+      </p:sp>
+      <p:sp>
+        <p:nvSpPr>
+          <p:cNvPr id="13" name="Screenshot app builder caption"/>
+          <p:cNvSpPr txBox="1"/>
+          <p:nvPr/>
+        </p:nvSpPr>
+        <p:spPr>
+          <a:xfrm>
+            <a:off x="841248" y="6263640"/>
+            <a:ext cx="5120640" cy="292608"/>
+          </a:xfrm>
+          <a:prstGeom prst="rect">
+            <a:avLst/>
+          </a:prstGeom>
+          <a:noFill/>
+          <a:ln/>
+        </p:spPr>
+        <p:txBody>
+          <a:bodyPr wrap="square" lIns="0" tIns="0" rIns="0" bIns="0" rtlCol="0" anchor="t"/>
+          <a:lstStyle/>
+          <a:p>
+            <a:pPr marL="0" indent="0" algn="l">
+              <a:buNone/>
+            </a:pPr>
+            <a:r>
+              <a:rPr lang="en-US" sz="1300" dirty="0">
+                <a:solidFill>
+                  <a:srgbClr val="7F7F7F"/>
+                </a:solidFill>
+              </a:rPr>
+              <a:t>Part-by-part builder</a:t>
+            </a:r>
+            <a:endParaRPr lang="en-US" sz="1300" dirty="0"/>
+          </a:p>
+        </p:txBody>
+      </p:sp>
+      <p:pic>
+        <p:nvPicPr>
+          <p:cNvPr id="14" name="Screenshot app score" descr="Performance Score panel and sidebar metrics (R², MAE, RMSE)"/>
+          <p:cNvPicPr>
+            <a:picLocks noChangeAspect="1"/>
+          </p:cNvPicPr>
+          <p:nvPr/>
+        </p:nvPicPr>
+        <p:blipFill>
+          <a:blip r:embed="rId4"/>
+          <a:stretch>
+            <a:fillRect/>
+          </a:stretch>
+        </p:blipFill>
+        <p:spPr>
+          <a:xfrm>
+            <a:off x="6622565" y="2926080"/>
+            <a:ext cx="4347925" cy="3291840"/>
+          </a:xfrm>
+          <a:prstGeom prst="rect">
+            <a:avLst/>
+          </a:prstGeom>
+        </p:spPr>
+      </p:pic>
+      <p:sp>
+        <p:nvSpPr>
+          <p:cNvPr id="15" name="Screenshot app score frame"/>
+          <p:cNvSpPr/>
+          <p:nvPr/>
+        </p:nvSpPr>
+        <p:spPr>
+          <a:xfrm>
+            <a:off x="6622565" y="2926080"/>
+            <a:ext cx="4347925" cy="3291840"/>
+          </a:xfrm>
+          <a:prstGeom prst="rect">
+            <a:avLst/>
+          </a:prstGeom>
+          <a:ln w="9525">
+            <a:solidFill>
+              <a:srgbClr val="9AA5B1"/>
+            </a:solidFill>
+            <a:prstDash val="solid"/>
+          </a:ln>
+        </p:spPr>
+        <p:txBody>
+          <a:bodyPr/>
+          <a:lstStyle/>
+          <a:p>
+            <a:endParaRPr lang="en-US"/>
+          </a:p>
+        </p:txBody>
+      </p:sp>
+      <p:sp>
+        <p:nvSpPr>
+          <p:cNvPr id="16" name="Screenshot app score caption"/>
+          <p:cNvSpPr txBox="1"/>
+          <p:nvPr/>
+        </p:nvSpPr>
+        <p:spPr>
+          <a:xfrm>
+            <a:off x="6236208" y="6263640"/>
+            <a:ext cx="5120640" cy="292608"/>
+          </a:xfrm>
+          <a:prstGeom prst="rect">
+            <a:avLst/>
+          </a:prstGeom>
+          <a:noFill/>
+          <a:ln/>
+        </p:spPr>
+        <p:txBody>
+          <a:bodyPr wrap="square" lIns="0" tIns="0" rIns="0" bIns="0" rtlCol="0" anchor="t"/>
+          <a:lstStyle/>
+          <a:p>
+            <a:pPr marL="0" indent="0" algn="l">
+              <a:buNone/>
+            </a:pPr>
+            <a:r>
+              <a:rPr lang="en-US" sz="1300" dirty="0">
+                <a:solidFill>
+                  <a:srgbClr val="7F7F7F"/>
+                </a:solidFill>
+              </a:rPr>
+              <a:t>Live score and model metrics in the sidebar</a:t>
             </a:r>
             <a:endParaRPr lang="en-US" sz="1300" dirty="0"/>
           </a:p>
@@ -14716,79 +14667,75 @@
                   <a:schemeClr val="accent1"/>
                 </a:solidFill>
               </a:rPr>
-              <a:t>Application Extras</a:t>
+              <a:t>What the Model Sees</a:t>
             </a:r>
             <a:endParaRPr lang="en-US" sz="2800" dirty="0"/>
           </a:p>
         </p:txBody>
       </p:sp>
+      <p:pic>
+        <p:nvPicPr>
+          <p:cNvPr id="3" name="Screenshot app inputs" descr="“What the model sees” tab"/>
+          <p:cNvPicPr>
+            <a:picLocks noChangeAspect="1"/>
+          </p:cNvPicPr>
+          <p:nvPr/>
+        </p:nvPicPr>
+        <p:blipFill>
+          <a:blip r:embed="rId3"/>
+          <a:stretch>
+            <a:fillRect/>
+          </a:stretch>
+        </p:blipFill>
+        <p:spPr>
+          <a:xfrm>
+            <a:off x="841248" y="1570322"/>
+            <a:ext cx="10515600" cy="3717357"/>
+          </a:xfrm>
+          <a:prstGeom prst="rect">
+            <a:avLst/>
+          </a:prstGeom>
+        </p:spPr>
+      </p:pic>
       <p:sp>
         <p:nvSpPr>
-          <p:cNvPr id="3" name="Screenshot compatibility"/>
+          <p:cNvPr id="4" name="Screenshot app inputs frame"/>
           <p:cNvSpPr/>
           <p:nvPr/>
         </p:nvSpPr>
         <p:spPr>
           <a:xfrm>
-            <a:off x="841248" y="1554480"/>
-            <a:ext cx="3383280" cy="3383280"/>
+            <a:off x="841248" y="1570322"/>
+            <a:ext cx="10515600" cy="3717357"/>
           </a:xfrm>
           <a:prstGeom prst="rect">
             <a:avLst/>
           </a:prstGeom>
-          <a:solidFill>
-            <a:srgbClr val="F7F9FC"/>
-          </a:solidFill>
-          <a:ln w="19050">
+          <a:ln w="9525">
             <a:solidFill>
               <a:srgbClr val="9AA5B1"/>
             </a:solidFill>
-            <a:prstDash val="dash"/>
+            <a:prstDash val="solid"/>
           </a:ln>
         </p:spPr>
         <p:txBody>
-          <a:bodyPr wrap="square" lIns="101600" tIns="101600" rIns="101600" bIns="101600" rtlCol="0" anchor="ctr"/>
+          <a:bodyPr/>
           <a:lstStyle/>
           <a:p>
-            <a:pPr marL="0" indent="0" algn="ctr">
-              <a:buNone/>
-            </a:pPr>
-            <a:r>
-              <a:rPr lang="en-US" sz="1400" b="1" dirty="0">
-                <a:solidFill>
-                  <a:srgbClr val="7F7F7F"/>
-                </a:solidFill>
-              </a:rPr>
-              <a:t>SCREENSHOT</a:t>
-            </a:r>
-            <a:endParaRPr lang="en-US" sz="1400" dirty="0"/>
-          </a:p>
-          <a:p>
-            <a:pPr marL="0" indent="0" algn="ctr">
-              <a:buNone/>
-            </a:pPr>
-            <a:r>
-              <a:rPr lang="en-US" sz="1300" dirty="0">
-                <a:solidFill>
-                  <a:srgbClr val="7F7F7F"/>
-                </a:solidFill>
-              </a:rPr>
-              <a:t>Build check: compatibility errors / warnings, power and temperature</a:t>
-            </a:r>
-            <a:endParaRPr lang="en-US" sz="1400" dirty="0"/>
+            <a:endParaRPr lang="en-US"/>
           </a:p>
         </p:txBody>
       </p:sp>
       <p:sp>
         <p:nvSpPr>
-          <p:cNvPr id="4" name="Screenshot compatibility caption"/>
+          <p:cNvPr id="5" name="Screenshot app inputs caption"/>
           <p:cNvSpPr txBox="1"/>
           <p:nvPr/>
         </p:nvSpPr>
         <p:spPr>
           <a:xfrm>
-            <a:off x="841248" y="4983480"/>
-            <a:ext cx="3383280" cy="292608"/>
+            <a:off x="841248" y="5349240"/>
+            <a:ext cx="10515600" cy="292608"/>
           </a:xfrm>
           <a:prstGeom prst="rect">
             <a:avLst/>
@@ -14809,7 +14756,7 @@
                   <a:srgbClr val="7F7F7F"/>
                 </a:solidFill>
               </a:rPr>
-              <a:t>Compatibility and power check</a:t>
+              <a:t>The 8 model inputs, each derived from the chosen parts</a:t>
             </a:r>
             <a:endParaRPr lang="en-US" sz="1300" dirty="0"/>
           </a:p>
@@ -14817,204 +14764,18 @@
       </p:sp>
       <p:sp>
         <p:nvSpPr>
-          <p:cNvPr id="5" name="Screenshot fps"/>
+          <p:cNvPr id="6" name="Inputs note"/>
           <p:cNvSpPr/>
           <p:nvPr/>
         </p:nvSpPr>
         <p:spPr>
           <a:xfrm>
-            <a:off x="4407408" y="1554480"/>
-            <a:ext cx="3383280" cy="3383280"/>
-          </a:xfrm>
-          <a:prstGeom prst="rect">
-            <a:avLst/>
-          </a:prstGeom>
-          <a:solidFill>
-            <a:srgbClr val="F7F9FC"/>
-          </a:solidFill>
-          <a:ln w="19050">
-            <a:solidFill>
-              <a:srgbClr val="9AA5B1"/>
-            </a:solidFill>
-            <a:prstDash val="dash"/>
-          </a:ln>
-        </p:spPr>
-        <p:txBody>
-          <a:bodyPr wrap="square" lIns="101600" tIns="101600" rIns="101600" bIns="101600" rtlCol="0" anchor="ctr"/>
-          <a:lstStyle/>
-          <a:p>
-            <a:pPr marL="0" indent="0" algn="ctr">
-              <a:buNone/>
-            </a:pPr>
-            <a:r>
-              <a:rPr lang="en-US" sz="1400" b="1" dirty="0">
-                <a:solidFill>
-                  <a:srgbClr val="7F7F7F"/>
-                </a:solidFill>
-              </a:rPr>
-              <a:t>SCREENSHOT</a:t>
-            </a:r>
-            <a:endParaRPr lang="en-US" sz="1400" dirty="0"/>
-          </a:p>
-          <a:p>
-            <a:pPr marL="0" indent="0" algn="ctr">
-              <a:buNone/>
-            </a:pPr>
-            <a:r>
-              <a:rPr lang="en-US" sz="1300" dirty="0">
-                <a:solidFill>
-                  <a:srgbClr val="7F7F7F"/>
-                </a:solidFill>
-              </a:rPr>
-              <a:t>Game FPS tab</a:t>
-            </a:r>
-            <a:endParaRPr lang="en-US" sz="1400" dirty="0"/>
-          </a:p>
-        </p:txBody>
-      </p:sp>
-      <p:sp>
-        <p:nvSpPr>
-          <p:cNvPr id="6" name="Screenshot fps caption"/>
-          <p:cNvSpPr txBox="1"/>
-          <p:nvPr/>
-        </p:nvSpPr>
-        <p:spPr>
-          <a:xfrm>
-            <a:off x="4407408" y="4983480"/>
-            <a:ext cx="3383280" cy="292608"/>
-          </a:xfrm>
-          <a:prstGeom prst="rect">
-            <a:avLst/>
-          </a:prstGeom>
-          <a:noFill/>
-          <a:ln/>
-        </p:spPr>
-        <p:txBody>
-          <a:bodyPr wrap="square" lIns="0" tIns="0" rIns="0" bIns="0" rtlCol="0" anchor="t"/>
-          <a:lstStyle/>
-          <a:p>
-            <a:pPr marL="0" indent="0" algn="l">
-              <a:buNone/>
-            </a:pPr>
-            <a:r>
-              <a:rPr lang="en-US" sz="1300" dirty="0">
-                <a:solidFill>
-                  <a:srgbClr val="7F7F7F"/>
-                </a:solidFill>
-              </a:rPr>
-              <a:t>Estimated game FPS</a:t>
-            </a:r>
-            <a:endParaRPr lang="en-US" sz="1300" dirty="0"/>
-          </a:p>
-        </p:txBody>
-      </p:sp>
-      <p:sp>
-        <p:nvSpPr>
-          <p:cNvPr id="7" name="Screenshot excel"/>
-          <p:cNvSpPr/>
-          <p:nvPr/>
-        </p:nvSpPr>
-        <p:spPr>
-          <a:xfrm>
-            <a:off x="7973568" y="1554480"/>
-            <a:ext cx="3383280" cy="3383280"/>
-          </a:xfrm>
-          <a:prstGeom prst="rect">
-            <a:avLst/>
-          </a:prstGeom>
-          <a:solidFill>
-            <a:srgbClr val="F7F9FC"/>
-          </a:solidFill>
-          <a:ln w="19050">
-            <a:solidFill>
-              <a:srgbClr val="9AA5B1"/>
-            </a:solidFill>
-            <a:prstDash val="dash"/>
-          </a:ln>
-        </p:spPr>
-        <p:txBody>
-          <a:bodyPr wrap="square" lIns="101600" tIns="101600" rIns="101600" bIns="101600" rtlCol="0" anchor="ctr"/>
-          <a:lstStyle/>
-          <a:p>
-            <a:pPr marL="0" indent="0" algn="ctr">
-              <a:buNone/>
-            </a:pPr>
-            <a:r>
-              <a:rPr lang="en-US" sz="1400" b="1" dirty="0">
-                <a:solidFill>
-                  <a:srgbClr val="7F7F7F"/>
-                </a:solidFill>
-              </a:rPr>
-              <a:t>SCREENSHOT</a:t>
-            </a:r>
-            <a:endParaRPr lang="en-US" sz="1400" dirty="0"/>
-          </a:p>
-          <a:p>
-            <a:pPr marL="0" indent="0" algn="ctr">
-              <a:buNone/>
-            </a:pPr>
-            <a:r>
-              <a:rPr lang="en-US" sz="1300" dirty="0">
-                <a:solidFill>
-                  <a:srgbClr val="7F7F7F"/>
-                </a:solidFill>
-              </a:rPr>
-              <a:t>Downloaded Excel build report</a:t>
-            </a:r>
-            <a:endParaRPr lang="en-US" sz="1400" dirty="0"/>
-          </a:p>
-        </p:txBody>
-      </p:sp>
-      <p:sp>
-        <p:nvSpPr>
-          <p:cNvPr id="8" name="Screenshot excel caption"/>
-          <p:cNvSpPr txBox="1"/>
-          <p:nvPr/>
-        </p:nvSpPr>
-        <p:spPr>
-          <a:xfrm>
-            <a:off x="7973568" y="4983480"/>
-            <a:ext cx="3383280" cy="292608"/>
-          </a:xfrm>
-          <a:prstGeom prst="rect">
-            <a:avLst/>
-          </a:prstGeom>
-          <a:noFill/>
-          <a:ln/>
-        </p:spPr>
-        <p:txBody>
-          <a:bodyPr wrap="square" lIns="0" tIns="0" rIns="0" bIns="0" rtlCol="0" anchor="t"/>
-          <a:lstStyle/>
-          <a:p>
-            <a:pPr marL="0" indent="0" algn="l">
-              <a:buNone/>
-            </a:pPr>
-            <a:r>
-              <a:rPr lang="en-US" sz="1300" dirty="0">
-                <a:solidFill>
-                  <a:srgbClr val="7F7F7F"/>
-                </a:solidFill>
-              </a:rPr>
-              <a:t>Excel report export</a:t>
-            </a:r>
-            <a:endParaRPr lang="en-US" sz="1300" dirty="0"/>
-          </a:p>
-        </p:txBody>
-      </p:sp>
-      <p:sp>
-        <p:nvSpPr>
-          <p:cNvPr id="9" name="Extras note"/>
-          <p:cNvSpPr/>
-          <p:nvPr/>
-        </p:nvSpPr>
-        <p:spPr>
-          <a:xfrm>
-            <a:off x="841248" y="5349240"/>
-            <a:ext cx="10515600" cy="1005840"/>
+            <a:off x="841248" y="5623560"/>
+            <a:ext cx="10515600" cy="777240"/>
           </a:xfrm>
           <a:prstGeom prst="roundRect">
             <a:avLst>
-              <a:gd name="adj" fmla="val 10909"/>
+              <a:gd name="adj" fmla="val 14118"/>
             </a:avLst>
           </a:prstGeom>
           <a:solidFill>
@@ -15037,14 +14798,14 @@
               <a:buNone/>
             </a:pPr>
             <a:r>
-              <a:rPr lang="en-US" sz="1400" dirty="0">
+              <a:rPr lang="en-US" sz="1500" dirty="0">
                 <a:solidFill>
                   <a:schemeClr val="tx1"/>
                 </a:solidFill>
               </a:rPr>
-              <a:t>Only the Performance Score comes from the ML model. Compatibility, power, temperature and FPS use rule-based formulas.</a:t>
-            </a:r>
-            <a:endParaRPr lang="en-US" sz="1400" dirty="0"/>
+              <a:t>The pipeline scales the 7 numeric inputs, one-hot encodes OS, and Linear Regression returns the score.</a:t>
+            </a:r>
+            <a:endParaRPr lang="en-US" sz="1500" dirty="0"/>
           </a:p>
         </p:txBody>
       </p:sp>
@@ -15107,6 +14868,385 @@
                   <a:schemeClr val="accent1"/>
                 </a:solidFill>
               </a:rPr>
+              <a:t>Application Extras</a:t>
+            </a:r>
+            <a:endParaRPr lang="en-US" sz="2800" dirty="0"/>
+          </a:p>
+        </p:txBody>
+      </p:sp>
+      <p:pic>
+        <p:nvPicPr>
+          <p:cNvPr id="3" name="Screenshot compatibility" descr="Build check: compatibility errors / warnings, power and temperature"/>
+          <p:cNvPicPr>
+            <a:picLocks noChangeAspect="1"/>
+          </p:cNvPicPr>
+          <p:nvPr/>
+        </p:nvPicPr>
+        <p:blipFill>
+          <a:blip r:embed="rId3"/>
+          <a:stretch>
+            <a:fillRect/>
+          </a:stretch>
+        </p:blipFill>
+        <p:spPr>
+          <a:xfrm>
+            <a:off x="841248" y="1708030"/>
+            <a:ext cx="2560320" cy="3441940"/>
+          </a:xfrm>
+          <a:prstGeom prst="rect">
+            <a:avLst/>
+          </a:prstGeom>
+        </p:spPr>
+      </p:pic>
+      <p:sp>
+        <p:nvSpPr>
+          <p:cNvPr id="4" name="Screenshot compatibility frame"/>
+          <p:cNvSpPr/>
+          <p:nvPr/>
+        </p:nvSpPr>
+        <p:spPr>
+          <a:xfrm>
+            <a:off x="841248" y="1708030"/>
+            <a:ext cx="2560320" cy="3441940"/>
+          </a:xfrm>
+          <a:prstGeom prst="rect">
+            <a:avLst/>
+          </a:prstGeom>
+          <a:ln w="9525">
+            <a:solidFill>
+              <a:srgbClr val="9AA5B1"/>
+            </a:solidFill>
+            <a:prstDash val="solid"/>
+          </a:ln>
+        </p:spPr>
+        <p:txBody>
+          <a:bodyPr/>
+          <a:lstStyle/>
+          <a:p>
+            <a:endParaRPr lang="en-US"/>
+          </a:p>
+        </p:txBody>
+      </p:sp>
+      <p:sp>
+        <p:nvSpPr>
+          <p:cNvPr id="5" name="Screenshot compatibility caption"/>
+          <p:cNvSpPr txBox="1"/>
+          <p:nvPr/>
+        </p:nvSpPr>
+        <p:spPr>
+          <a:xfrm>
+            <a:off x="841248" y="5349240"/>
+            <a:ext cx="2560320" cy="292608"/>
+          </a:xfrm>
+          <a:prstGeom prst="rect">
+            <a:avLst/>
+          </a:prstGeom>
+          <a:noFill/>
+          <a:ln/>
+        </p:spPr>
+        <p:txBody>
+          <a:bodyPr wrap="square" lIns="0" tIns="0" rIns="0" bIns="0" rtlCol="0" anchor="t"/>
+          <a:lstStyle/>
+          <a:p>
+            <a:pPr marL="0" indent="0" algn="l">
+              <a:buNone/>
+            </a:pPr>
+            <a:r>
+              <a:rPr lang="en-US" sz="1300" dirty="0">
+                <a:solidFill>
+                  <a:srgbClr val="7F7F7F"/>
+                </a:solidFill>
+              </a:rPr>
+              <a:t>Build check (example: PSU headroom warning)</a:t>
+            </a:r>
+            <a:endParaRPr lang="en-US" sz="1300" dirty="0"/>
+          </a:p>
+        </p:txBody>
+      </p:sp>
+      <p:pic>
+        <p:nvPicPr>
+          <p:cNvPr id="6" name="Screenshot fps" descr="Game FPS tab"/>
+          <p:cNvPicPr>
+            <a:picLocks noChangeAspect="1"/>
+          </p:cNvPicPr>
+          <p:nvPr/>
+        </p:nvPicPr>
+        <p:blipFill>
+          <a:blip r:embed="rId4"/>
+          <a:stretch>
+            <a:fillRect/>
+          </a:stretch>
+        </p:blipFill>
+        <p:spPr>
+          <a:xfrm>
+            <a:off x="3630168" y="2048416"/>
+            <a:ext cx="4754880" cy="2761167"/>
+          </a:xfrm>
+          <a:prstGeom prst="rect">
+            <a:avLst/>
+          </a:prstGeom>
+        </p:spPr>
+      </p:pic>
+      <p:sp>
+        <p:nvSpPr>
+          <p:cNvPr id="7" name="Screenshot fps frame"/>
+          <p:cNvSpPr/>
+          <p:nvPr/>
+        </p:nvSpPr>
+        <p:spPr>
+          <a:xfrm>
+            <a:off x="3630168" y="2048416"/>
+            <a:ext cx="4754880" cy="2761167"/>
+          </a:xfrm>
+          <a:prstGeom prst="rect">
+            <a:avLst/>
+          </a:prstGeom>
+          <a:ln w="9525">
+            <a:solidFill>
+              <a:srgbClr val="9AA5B1"/>
+            </a:solidFill>
+            <a:prstDash val="solid"/>
+          </a:ln>
+        </p:spPr>
+        <p:txBody>
+          <a:bodyPr/>
+          <a:lstStyle/>
+          <a:p>
+            <a:endParaRPr lang="en-US"/>
+          </a:p>
+        </p:txBody>
+      </p:sp>
+      <p:sp>
+        <p:nvSpPr>
+          <p:cNvPr id="8" name="Screenshot fps caption"/>
+          <p:cNvSpPr txBox="1"/>
+          <p:nvPr/>
+        </p:nvSpPr>
+        <p:spPr>
+          <a:xfrm>
+            <a:off x="3630168" y="5349240"/>
+            <a:ext cx="4754880" cy="292608"/>
+          </a:xfrm>
+          <a:prstGeom prst="rect">
+            <a:avLst/>
+          </a:prstGeom>
+          <a:noFill/>
+          <a:ln/>
+        </p:spPr>
+        <p:txBody>
+          <a:bodyPr wrap="square" lIns="0" tIns="0" rIns="0" bIns="0" rtlCol="0" anchor="t"/>
+          <a:lstStyle/>
+          <a:p>
+            <a:pPr marL="0" indent="0" algn="l">
+              <a:buNone/>
+            </a:pPr>
+            <a:r>
+              <a:rPr lang="en-US" sz="1300" dirty="0">
+                <a:solidFill>
+                  <a:srgbClr val="7F7F7F"/>
+                </a:solidFill>
+              </a:rPr>
+              <a:t>Estimated game FPS</a:t>
+            </a:r>
+            <a:endParaRPr lang="en-US" sz="1300" dirty="0"/>
+          </a:p>
+        </p:txBody>
+      </p:sp>
+      <p:pic>
+        <p:nvPicPr>
+          <p:cNvPr id="9" name="Screenshot excel" descr="Downloaded Excel build report"/>
+          <p:cNvPicPr>
+            <a:picLocks noChangeAspect="1"/>
+          </p:cNvPicPr>
+          <p:nvPr/>
+        </p:nvPicPr>
+        <p:blipFill>
+          <a:blip r:embed="rId5"/>
+          <a:stretch>
+            <a:fillRect/>
+          </a:stretch>
+        </p:blipFill>
+        <p:spPr>
+          <a:xfrm>
+            <a:off x="8613648" y="2544631"/>
+            <a:ext cx="2743200" cy="1768739"/>
+          </a:xfrm>
+          <a:prstGeom prst="rect">
+            <a:avLst/>
+          </a:prstGeom>
+        </p:spPr>
+      </p:pic>
+      <p:sp>
+        <p:nvSpPr>
+          <p:cNvPr id="10" name="Screenshot excel frame"/>
+          <p:cNvSpPr/>
+          <p:nvPr/>
+        </p:nvSpPr>
+        <p:spPr>
+          <a:xfrm>
+            <a:off x="8613648" y="2544631"/>
+            <a:ext cx="2743200" cy="1768739"/>
+          </a:xfrm>
+          <a:prstGeom prst="rect">
+            <a:avLst/>
+          </a:prstGeom>
+          <a:ln w="9525">
+            <a:solidFill>
+              <a:srgbClr val="9AA5B1"/>
+            </a:solidFill>
+            <a:prstDash val="solid"/>
+          </a:ln>
+        </p:spPr>
+        <p:txBody>
+          <a:bodyPr/>
+          <a:lstStyle/>
+          <a:p>
+            <a:endParaRPr lang="en-US"/>
+          </a:p>
+        </p:txBody>
+      </p:sp>
+      <p:sp>
+        <p:nvSpPr>
+          <p:cNvPr id="11" name="Screenshot excel caption"/>
+          <p:cNvSpPr txBox="1"/>
+          <p:nvPr/>
+        </p:nvSpPr>
+        <p:spPr>
+          <a:xfrm>
+            <a:off x="8613648" y="5349240"/>
+            <a:ext cx="2743200" cy="292608"/>
+          </a:xfrm>
+          <a:prstGeom prst="rect">
+            <a:avLst/>
+          </a:prstGeom>
+          <a:noFill/>
+          <a:ln/>
+        </p:spPr>
+        <p:txBody>
+          <a:bodyPr wrap="square" lIns="0" tIns="0" rIns="0" bIns="0" rtlCol="0" anchor="t"/>
+          <a:lstStyle/>
+          <a:p>
+            <a:pPr marL="0" indent="0" algn="l">
+              <a:buNone/>
+            </a:pPr>
+            <a:r>
+              <a:rPr lang="en-US" sz="1300" dirty="0">
+                <a:solidFill>
+                  <a:srgbClr val="7F7F7F"/>
+                </a:solidFill>
+              </a:rPr>
+              <a:t>Excel report export</a:t>
+            </a:r>
+            <a:endParaRPr lang="en-US" sz="1300" dirty="0"/>
+          </a:p>
+        </p:txBody>
+      </p:sp>
+      <p:sp>
+        <p:nvSpPr>
+          <p:cNvPr id="12" name="Extras note"/>
+          <p:cNvSpPr/>
+          <p:nvPr/>
+        </p:nvSpPr>
+        <p:spPr>
+          <a:xfrm>
+            <a:off x="841248" y="5792885"/>
+            <a:ext cx="10515600" cy="777240"/>
+          </a:xfrm>
+          <a:prstGeom prst="roundRect">
+            <a:avLst>
+              <a:gd name="adj" fmla="val 14118"/>
+            </a:avLst>
+          </a:prstGeom>
+          <a:solidFill>
+            <a:schemeClr val="bg2"/>
+          </a:solidFill>
+          <a:ln/>
+          <a:effectLst>
+            <a:outerShdw blurRad="76200" dist="25400" dir="5400000" algn="bl" rotWithShape="0">
+              <a:srgbClr val="000000">
+                <a:alpha val="22000"/>
+              </a:srgbClr>
+            </a:outerShdw>
+          </a:effectLst>
+        </p:spPr>
+        <p:txBody>
+          <a:bodyPr wrap="square" lIns="101600" tIns="152400" rIns="152400" bIns="76200" rtlCol="0" anchor="ctr"/>
+          <a:lstStyle/>
+          <a:p>
+            <a:pPr marL="0" indent="0" algn="l">
+              <a:buNone/>
+            </a:pPr>
+            <a:r>
+              <a:rPr lang="en-US" sz="1500" dirty="0">
+                <a:solidFill>
+                  <a:schemeClr val="tx1"/>
+                </a:solidFill>
+              </a:rPr>
+              <a:t>Only the Performance Score comes from the ML model. Compatibility, power, temperature and FPS use rule-based formulas.</a:t>
+            </a:r>
+            <a:endParaRPr lang="en-US" sz="1500" dirty="0"/>
+          </a:p>
+        </p:txBody>
+      </p:sp>
+    </p:spTree>
+  </p:cSld>
+  <p:clrMapOvr>
+    <a:masterClrMapping/>
+  </p:clrMapOvr>
+</p:sld>
+</file>
+
+<file path=ppt/slides/slide25.xml><?xml version="1.0" encoding="utf-8"?>
+<p:sld xmlns:a="http://schemas.openxmlformats.org/drawingml/2006/main" xmlns:r="http://schemas.openxmlformats.org/officeDocument/2006/relationships" xmlns:p="http://schemas.openxmlformats.org/presentationml/2006/main">
+  <p:cSld name="Slide 25">
+    <p:spTree>
+      <p:nvGrpSpPr>
+        <p:cNvPr id="1" name=""/>
+        <p:cNvGrpSpPr/>
+        <p:nvPr/>
+      </p:nvGrpSpPr>
+      <p:grpSpPr>
+        <a:xfrm>
+          <a:off x="0" y="0"/>
+          <a:ext cx="0" cy="0"/>
+          <a:chOff x="0" y="0"/>
+          <a:chExt cx="0" cy="0"/>
+        </a:xfrm>
+      </p:grpSpPr>
+      <p:sp>
+        <p:nvSpPr>
+          <p:cNvPr id="2" name="Text 0"/>
+          <p:cNvSpPr>
+            <a:spLocks noGrp="1"/>
+          </p:cNvSpPr>
+          <p:nvPr>
+            <p:ph type="title" idx="101" hasCustomPrompt="1"/>
+          </p:nvPr>
+        </p:nvSpPr>
+        <p:spPr>
+          <a:xfrm>
+            <a:off x="2194560" y="393192"/>
+            <a:ext cx="7772400" cy="521208"/>
+          </a:xfrm>
+          <a:prstGeom prst="rect">
+            <a:avLst/>
+          </a:prstGeom>
+          <a:noFill/>
+          <a:ln/>
+        </p:spPr>
+        <p:txBody>
+          <a:bodyPr wrap="square" lIns="0" tIns="0" rIns="0" bIns="0" rtlCol="0" anchor="ctr"/>
+          <a:lstStyle/>
+          <a:p>
+            <a:pPr marL="0" indent="0" algn="ctr">
+              <a:buNone/>
+            </a:pPr>
+            <a:r>
+              <a:rPr lang="en-US" sz="2800" b="1" dirty="0">
+                <a:solidFill>
+                  <a:schemeClr val="accent1"/>
+                </a:solidFill>
+              </a:rPr>
               <a:t>Conclusion</a:t>
             </a:r>
             <a:endParaRPr lang="en-US" sz="2800" dirty="0"/>
@@ -15142,7 +15282,7 @@
           </a:effectLst>
         </p:spPr>
         <p:txBody>
-          <a:bodyPr wrap="square" lIns="101600" tIns="152400" rIns="152400" bIns="76200" rtlCol="0" anchor="ctr"/>
+          <a:bodyPr wrap="square" lIns="101600" tIns="152400" rIns="152400" bIns="76200" rtlCol="0" anchor="t"/>
           <a:lstStyle/>
           <a:p>
             <a:pPr marL="0" indent="0" algn="l">
@@ -15264,7 +15404,7 @@
           </a:effectLst>
         </p:spPr>
         <p:txBody>
-          <a:bodyPr wrap="square" lIns="101600" tIns="152400" rIns="152400" bIns="76200" rtlCol="0" anchor="ctr"/>
+          <a:bodyPr wrap="square" lIns="101600" tIns="152400" rIns="152400" bIns="76200" rtlCol="0" anchor="t"/>
           <a:lstStyle/>
           <a:p>
             <a:pPr marL="0" indent="0" algn="l">
@@ -15365,9 +15505,9 @@
 </p:sld>
 </file>
 
-<file path=ppt/slides/slide25.xml><?xml version="1.0" encoding="utf-8"?>
+<file path=ppt/slides/slide26.xml><?xml version="1.0" encoding="utf-8"?>
 <p:sld xmlns:a="http://schemas.openxmlformats.org/drawingml/2006/main" xmlns:r="http://schemas.openxmlformats.org/officeDocument/2006/relationships" xmlns:p="http://schemas.openxmlformats.org/presentationml/2006/main">
-  <p:cSld name="Slide 25">
+  <p:cSld name="Slide 26">
     <p:spTree>
       <p:nvGrpSpPr>
         <p:cNvPr id="1" name=""/>
@@ -15620,7 +15760,7 @@
           </a:effectLst>
         </p:spPr>
         <p:txBody>
-          <a:bodyPr wrap="square" lIns="101600" tIns="152400" rIns="152400" bIns="76200" rtlCol="0" anchor="ctr"/>
+          <a:bodyPr wrap="square" lIns="101600" tIns="152400" rIns="152400" bIns="76200" rtlCol="0" anchor="t"/>
           <a:lstStyle/>
           <a:p>
             <a:pPr marL="0" indent="0" algn="l">
@@ -15742,7 +15882,7 @@
           </a:effectLst>
         </p:spPr>
         <p:txBody>
-          <a:bodyPr wrap="square" lIns="101600" tIns="152400" rIns="152400" bIns="76200" rtlCol="0" anchor="ctr"/>
+          <a:bodyPr wrap="square" lIns="101600" tIns="152400" rIns="152400" bIns="76200" rtlCol="0" anchor="t"/>
           <a:lstStyle/>
           <a:p>
             <a:pPr marL="0" indent="0" algn="l">
@@ -16005,6 +16145,13 @@
             <a:tailEnd type="triangle"/>
           </a:ln>
         </p:spPr>
+        <p:txBody>
+          <a:bodyPr/>
+          <a:lstStyle/>
+          <a:p>
+            <a:endParaRPr lang="en-US"/>
+          </a:p>
+        </p:txBody>
       </p:sp>
       <p:sp>
         <p:nvSpPr>
@@ -16093,6 +16240,13 @@
             <a:tailEnd type="triangle"/>
           </a:ln>
         </p:spPr>
+        <p:txBody>
+          <a:bodyPr/>
+          <a:lstStyle/>
+          <a:p>
+            <a:endParaRPr lang="en-US"/>
+          </a:p>
+        </p:txBody>
       </p:sp>
       <p:sp>
         <p:nvSpPr>
@@ -16181,6 +16335,13 @@
             <a:tailEnd type="triangle"/>
           </a:ln>
         </p:spPr>
+        <p:txBody>
+          <a:bodyPr/>
+          <a:lstStyle/>
+          <a:p>
+            <a:endParaRPr lang="en-US"/>
+          </a:p>
+        </p:txBody>
       </p:sp>
       <p:sp>
         <p:nvSpPr>
@@ -16275,7 +16436,7 @@
           </a:effectLst>
         </p:spPr>
         <p:txBody>
-          <a:bodyPr wrap="square" lIns="101600" tIns="152400" rIns="152400" bIns="76200" rtlCol="0" anchor="ctr"/>
+          <a:bodyPr wrap="square" lIns="101600" tIns="152400" rIns="152400" bIns="76200" rtlCol="0" anchor="t"/>
           <a:lstStyle/>
           <a:p>
             <a:pPr marL="0" indent="0" algn="l">
@@ -16384,7 +16545,7 @@
           <p:nvPr>
             <p:extLst>
               <p:ext uri="{D42A27DB-BD31-4B8C-83A1-F6EECF244321}">
-                <p14:modId xmlns:p14="http://schemas.microsoft.com/office/powerpoint/2010/main" val="426856819"/>
+                <p14:modId xmlns:p14="http://schemas.microsoft.com/office/powerpoint/2010/main" val="1579011935"/>
               </p:ext>
             </p:extLst>
           </p:nvPr>
@@ -16876,7 +17037,7 @@
                             <a:schemeClr val="tx1"/>
                           </a:solidFill>
                         </a:rPr>
-                        <a:t>Key</a:t>
+                        <a:t>Key, not a feature</a:t>
                       </a:r>
                       <a:endParaRPr lang="en-US" sz="1200" dirty="0"/>
                     </a:p>
@@ -19472,7 +19633,7 @@
           </a:effectLst>
         </p:spPr>
         <p:txBody>
-          <a:bodyPr wrap="square" lIns="101600" tIns="152400" rIns="152400" bIns="76200" rtlCol="0" anchor="ctr"/>
+          <a:bodyPr wrap="square" lIns="101600" tIns="152400" rIns="152400" bIns="76200" rtlCol="0" anchor="t"/>
           <a:lstStyle/>
           <a:p>
             <a:pPr marL="0" indent="0" algn="l">
@@ -19578,6 +19739,24 @@
                 </a:solidFill>
               </a:rPr>
               <a:t>Windows 377, Linux 126.</a:t>
+            </a:r>
+            <a:endParaRPr lang="en-US" sz="1800" dirty="0"/>
+          </a:p>
+          <a:p>
+            <a:pPr marL="342900" indent="-342900" algn="l">
+              <a:spcAft>
+                <a:spcPts val="500"/>
+              </a:spcAft>
+              <a:buSzPct val="100000"/>
+              <a:buChar char="•"/>
+            </a:pPr>
+            <a:r>
+              <a:rPr lang="en-US" sz="1600" dirty="0">
+                <a:solidFill>
+                  <a:schemeClr val="tx1"/>
+                </a:solidFill>
+              </a:rPr>
+              <a:t>Record_ID is never a feature.</a:t>
             </a:r>
             <a:endParaRPr lang="en-US" sz="1800" dirty="0"/>
           </a:p>
@@ -19921,7 +20100,7 @@
           </a:effectLst>
         </p:spPr>
         <p:txBody>
-          <a:bodyPr wrap="square" lIns="101600" tIns="152400" rIns="152400" bIns="76200" rtlCol="0" anchor="ctr"/>
+          <a:bodyPr wrap="square" lIns="101600" tIns="152400" rIns="152400" bIns="76200" rtlCol="0" anchor="t"/>
           <a:lstStyle/>
           <a:p>
             <a:pPr marL="0" indent="0" algn="l">
@@ -20063,7 +20242,7 @@
           </a:effectLst>
         </p:spPr>
         <p:txBody>
-          <a:bodyPr wrap="square" lIns="101600" tIns="152400" rIns="152400" bIns="76200" rtlCol="0" anchor="ctr"/>
+          <a:bodyPr wrap="square" lIns="101600" tIns="152400" rIns="152400" bIns="76200" rtlCol="0" anchor="t"/>
           <a:lstStyle/>
           <a:p>
             <a:pPr marL="0" indent="0" algn="l">
@@ -20250,7 +20429,7 @@
           </a:effectLst>
         </p:spPr>
         <p:txBody>
-          <a:bodyPr wrap="square" lIns="101600" tIns="152400" rIns="152400" bIns="76200" rtlCol="0" anchor="ctr"/>
+          <a:bodyPr wrap="square" lIns="101600" tIns="152400" rIns="152400" bIns="76200" rtlCol="0" anchor="t"/>
           <a:lstStyle/>
           <a:p>
             <a:pPr marL="0" indent="0" algn="l">
@@ -20361,66 +20540,62 @@
           </a:p>
         </p:txBody>
       </p:sp>
+      <p:pic>
+        <p:nvPicPr>
+          <p:cNvPr id="4" name="Screenshot preprocessing" descr="Terminal output of python src/preprocess.py"/>
+          <p:cNvPicPr>
+            <a:picLocks noChangeAspect="1"/>
+          </p:cNvPicPr>
+          <p:nvPr/>
+        </p:nvPicPr>
+        <p:blipFill>
+          <a:blip r:embed="rId3"/>
+          <a:stretch>
+            <a:fillRect/>
+          </a:stretch>
+        </p:blipFill>
+        <p:spPr>
+          <a:xfrm>
+            <a:off x="4937760" y="2676525"/>
+            <a:ext cx="6400800" cy="2053590"/>
+          </a:xfrm>
+          <a:prstGeom prst="rect">
+            <a:avLst/>
+          </a:prstGeom>
+        </p:spPr>
+      </p:pic>
       <p:sp>
         <p:nvSpPr>
-          <p:cNvPr id="4" name="Screenshot preprocessing"/>
+          <p:cNvPr id="5" name="Screenshot preprocessing frame"/>
           <p:cNvSpPr/>
           <p:nvPr/>
         </p:nvSpPr>
         <p:spPr>
           <a:xfrm>
-            <a:off x="4937760" y="1554480"/>
-            <a:ext cx="6400800" cy="4297680"/>
+            <a:off x="4937760" y="2676525"/>
+            <a:ext cx="6400800" cy="2053590"/>
           </a:xfrm>
           <a:prstGeom prst="rect">
             <a:avLst/>
           </a:prstGeom>
-          <a:solidFill>
-            <a:srgbClr val="F7F9FC"/>
-          </a:solidFill>
-          <a:ln w="19050">
+          <a:ln w="9525">
             <a:solidFill>
               <a:srgbClr val="9AA5B1"/>
             </a:solidFill>
-            <a:prstDash val="dash"/>
+            <a:prstDash val="solid"/>
           </a:ln>
         </p:spPr>
         <p:txBody>
-          <a:bodyPr wrap="square" lIns="101600" tIns="101600" rIns="101600" bIns="101600" rtlCol="0" anchor="ctr"/>
+          <a:bodyPr/>
           <a:lstStyle/>
           <a:p>
-            <a:pPr marL="0" indent="0" algn="ctr">
-              <a:buNone/>
-            </a:pPr>
-            <a:r>
-              <a:rPr lang="en-US" sz="1400" b="1" dirty="0">
-                <a:solidFill>
-                  <a:srgbClr val="7F7F7F"/>
-                </a:solidFill>
-              </a:rPr>
-              <a:t>SCREENSHOT</a:t>
-            </a:r>
-            <a:endParaRPr lang="en-US" sz="1400" dirty="0"/>
-          </a:p>
-          <a:p>
-            <a:pPr marL="0" indent="0" algn="ctr">
-              <a:buNone/>
-            </a:pPr>
-            <a:r>
-              <a:rPr lang="en-US" sz="1300" dirty="0">
-                <a:solidFill>
-                  <a:srgbClr val="7F7F7F"/>
-                </a:solidFill>
-              </a:rPr>
-              <a:t>Terminal output of python src/preprocess.py</a:t>
-            </a:r>
-            <a:endParaRPr lang="en-US" sz="1400" dirty="0"/>
+            <a:endParaRPr lang="en-US"/>
           </a:p>
         </p:txBody>
       </p:sp>
       <p:sp>
         <p:nvSpPr>
-          <p:cNvPr id="5" name="Screenshot preprocessing caption"/>
+          <p:cNvPr id="6" name="Screenshot preprocessing caption"/>
           <p:cNvSpPr txBox="1"/>
           <p:nvPr/>
         </p:nvSpPr>
@@ -20792,7 +20967,7 @@
           </a:effectLst>
         </p:spPr>
         <p:txBody>
-          <a:bodyPr wrap="square" lIns="101600" tIns="152400" rIns="152400" bIns="76200" rtlCol="0" anchor="ctr"/>
+          <a:bodyPr wrap="square" lIns="101600" tIns="152400" rIns="152400" bIns="76200" rtlCol="0" anchor="t"/>
           <a:lstStyle/>
           <a:p>
             <a:pPr marL="0" indent="0" algn="l">
@@ -20950,7 +21125,7 @@
           </a:effectLst>
         </p:spPr>
         <p:txBody>
-          <a:bodyPr wrap="square" lIns="101600" tIns="152400" rIns="152400" bIns="76200" rtlCol="0" anchor="ctr"/>
+          <a:bodyPr wrap="square" lIns="101600" tIns="152400" rIns="152400" bIns="76200" rtlCol="0" anchor="t"/>
           <a:lstStyle/>
           <a:p>
             <a:pPr marL="0" indent="0" algn="l">
@@ -21119,7 +21294,7 @@
           </a:effectLst>
         </p:spPr>
         <p:txBody>
-          <a:bodyPr wrap="square" lIns="101600" tIns="152400" rIns="152400" bIns="76200" rtlCol="0" anchor="ctr"/>
+          <a:bodyPr wrap="square" lIns="101600" tIns="152400" rIns="152400" bIns="76200" rtlCol="0" anchor="t"/>
           <a:lstStyle/>
           <a:p>
             <a:pPr marL="0" indent="0" algn="l">
@@ -21230,66 +21405,62 @@
           </a:p>
         </p:txBody>
       </p:sp>
+      <p:pic>
+        <p:nvPicPr>
+          <p:cNvPr id="4" name="Screenshot scaling" descr="Before / after scaling (describe() output or notebook cell)"/>
+          <p:cNvPicPr>
+            <a:picLocks noChangeAspect="1"/>
+          </p:cNvPicPr>
+          <p:nvPr/>
+        </p:nvPicPr>
+        <p:blipFill>
+          <a:blip r:embed="rId3"/>
+          <a:stretch>
+            <a:fillRect/>
+          </a:stretch>
+        </p:blipFill>
+        <p:spPr>
+          <a:xfrm>
+            <a:off x="7304631" y="1554480"/>
+            <a:ext cx="3605587" cy="3931920"/>
+          </a:xfrm>
+          <a:prstGeom prst="rect">
+            <a:avLst/>
+          </a:prstGeom>
+        </p:spPr>
+      </p:pic>
       <p:sp>
         <p:nvSpPr>
-          <p:cNvPr id="4" name="Screenshot scaling"/>
+          <p:cNvPr id="5" name="Screenshot scaling frame"/>
           <p:cNvSpPr/>
           <p:nvPr/>
         </p:nvSpPr>
         <p:spPr>
           <a:xfrm>
-            <a:off x="6858000" y="1554480"/>
-            <a:ext cx="4498848" cy="3931920"/>
+            <a:off x="7304631" y="1554480"/>
+            <a:ext cx="3605587" cy="3931920"/>
           </a:xfrm>
           <a:prstGeom prst="rect">
             <a:avLst/>
           </a:prstGeom>
-          <a:solidFill>
-            <a:srgbClr val="F7F9FC"/>
-          </a:solidFill>
-          <a:ln w="19050">
+          <a:ln w="9525">
             <a:solidFill>
               <a:srgbClr val="9AA5B1"/>
             </a:solidFill>
-            <a:prstDash val="dash"/>
+            <a:prstDash val="solid"/>
           </a:ln>
         </p:spPr>
         <p:txBody>
-          <a:bodyPr wrap="square" lIns="101600" tIns="101600" rIns="101600" bIns="101600" rtlCol="0" anchor="ctr"/>
+          <a:bodyPr/>
           <a:lstStyle/>
           <a:p>
-            <a:pPr marL="0" indent="0" algn="ctr">
-              <a:buNone/>
-            </a:pPr>
-            <a:r>
-              <a:rPr lang="en-US" sz="1400" b="1" dirty="0">
-                <a:solidFill>
-                  <a:srgbClr val="7F7F7F"/>
-                </a:solidFill>
-              </a:rPr>
-              <a:t>SCREENSHOT</a:t>
-            </a:r>
-            <a:endParaRPr lang="en-US" sz="1400" dirty="0"/>
-          </a:p>
-          <a:p>
-            <a:pPr marL="0" indent="0" algn="ctr">
-              <a:buNone/>
-            </a:pPr>
-            <a:r>
-              <a:rPr lang="en-US" sz="1300" dirty="0">
-                <a:solidFill>
-                  <a:srgbClr val="7F7F7F"/>
-                </a:solidFill>
-              </a:rPr>
-              <a:t>Before / after scaling (describe() output or notebook cell)</a:t>
-            </a:r>
-            <a:endParaRPr lang="en-US" sz="1400" dirty="0"/>
+            <a:endParaRPr lang="en-US"/>
           </a:p>
         </p:txBody>
       </p:sp>
       <p:sp>
         <p:nvSpPr>
-          <p:cNvPr id="5" name="Screenshot scaling caption"/>
+          <p:cNvPr id="6" name="Screenshot scaling caption"/>
           <p:cNvSpPr txBox="1"/>
           <p:nvPr/>
         </p:nvSpPr>
@@ -21637,39 +21808,39 @@
         <a:sysClr val="window" lastClr="FFFFFF"/>
       </a:lt1>
       <a:dk2>
-        <a:srgbClr val="44546A"/>
+        <a:srgbClr val="0E2841"/>
       </a:dk2>
       <a:lt2>
-        <a:srgbClr val="E7E6E6"/>
+        <a:srgbClr val="E8E8E8"/>
       </a:lt2>
       <a:accent1>
-        <a:srgbClr val="4472C4"/>
+        <a:srgbClr val="156082"/>
       </a:accent1>
       <a:accent2>
-        <a:srgbClr val="ED7D31"/>
+        <a:srgbClr val="E97132"/>
       </a:accent2>
       <a:accent3>
-        <a:srgbClr val="A5A5A5"/>
+        <a:srgbClr val="196B24"/>
       </a:accent3>
       <a:accent4>
-        <a:srgbClr val="FFC000"/>
+        <a:srgbClr val="0F9ED5"/>
       </a:accent4>
       <a:accent5>
-        <a:srgbClr val="5B9BD5"/>
+        <a:srgbClr val="A02B93"/>
       </a:accent5>
       <a:accent6>
-        <a:srgbClr val="70AD47"/>
+        <a:srgbClr val="4EA72E"/>
       </a:accent6>
       <a:hlink>
-        <a:srgbClr val="0563C1"/>
+        <a:srgbClr val="467886"/>
       </a:hlink>
       <a:folHlink>
-        <a:srgbClr val="954F72"/>
+        <a:srgbClr val="96607D"/>
       </a:folHlink>
     </a:clrScheme>
     <a:fontScheme name="Office">
       <a:majorFont>
-        <a:latin typeface="Calibri Light" panose="020F0302020204030204"/>
+        <a:latin typeface="Aptos Display" panose="02110004020202020204"/>
         <a:ea typeface=""/>
         <a:cs typeface=""/>
         <a:font script="Jpan" typeface="游ゴシック Light"/>
@@ -21721,7 +21892,7 @@
         <a:font script="Tfng" typeface="Ebrima"/>
       </a:majorFont>
       <a:minorFont>
-        <a:latin typeface="Calibri" panose="020F0502020204030204"/>
+        <a:latin typeface="Aptos" panose="02110004020202020204"/>
         <a:ea typeface=""/>
         <a:cs typeface=""/>
         <a:font script="Jpan" typeface="游ゴシック"/>
@@ -21832,13 +22003,6 @@
         </a:gradFill>
       </a:fillStyleLst>
       <a:lnStyleLst>
-        <a:ln w="6350" cap="flat" cmpd="sng" algn="ctr">
-          <a:solidFill>
-            <a:schemeClr val="phClr"/>
-          </a:solidFill>
-          <a:prstDash val="solid"/>
-          <a:miter lim="800000"/>
-        </a:ln>
         <a:ln w="12700" cap="flat" cmpd="sng" algn="ctr">
           <a:solidFill>
             <a:schemeClr val="phClr"/>
@@ -21847,6 +22011,13 @@
           <a:miter lim="800000"/>
         </a:ln>
         <a:ln w="19050" cap="flat" cmpd="sng" algn="ctr">
+          <a:solidFill>
+            <a:schemeClr val="phClr"/>
+          </a:solidFill>
+          <a:prstDash val="solid"/>
+          <a:miter lim="800000"/>
+        </a:ln>
+        <a:ln w="25400" cap="flat" cmpd="sng" algn="ctr">
           <a:solidFill>
             <a:schemeClr val="phClr"/>
           </a:solidFill>
@@ -21911,11 +22082,31 @@
       </a:bgFillStyleLst>
     </a:fmtScheme>
   </a:themeElements>
-  <a:objectDefaults/>
+  <a:objectDefaults>
+    <a:lnDef>
+      <a:spPr/>
+      <a:bodyPr/>
+      <a:lstStyle/>
+      <a:style>
+        <a:lnRef idx="2">
+          <a:schemeClr val="accent1"/>
+        </a:lnRef>
+        <a:fillRef idx="0">
+          <a:schemeClr val="accent1"/>
+        </a:fillRef>
+        <a:effectRef idx="1">
+          <a:schemeClr val="accent1"/>
+        </a:effectRef>
+        <a:fontRef idx="minor">
+          <a:schemeClr val="tx1"/>
+        </a:fontRef>
+      </a:style>
+    </a:lnDef>
+  </a:objectDefaults>
   <a:extraClrSchemeLst/>
   <a:extLst>
     <a:ext uri="{05A4C25C-085E-4340-85A3-A5531E510DB2}">
-      <thm15:themeFamily xmlns:thm15="http://schemas.microsoft.com/office/thememl/2012/main" name="Office Theme" id="{62F939B6-93AF-4DB8-9C6B-D6C7DFDC589F}" vid="{4A3C46E8-61CC-4603-A589-7422A47A8E4A}"/>
+      <thm15:themeFamily xmlns:thm15="http://schemas.microsoft.com/office/thememl/2012/main" name="Office Theme" id="{2E142A2C-CD16-42D6-873A-C26D2A0506FA}" vid="{1BDDFF52-6CD6-40A5-AB3C-68EB2F1E4D0A}"/>
     </a:ext>
   </a:extLst>
 </a:theme>

</xml_diff>

<commit_message>
Update ML review presentation
</commit_message>
<xml_diff>
--- a/PC_Performance_Predictor_ML_Review.pptx
+++ b/PC_Performance_Predictor_ML_Review.pptx
@@ -16545,7 +16545,7 @@
           <p:nvPr>
             <p:extLst>
               <p:ext uri="{D42A27DB-BD31-4B8C-83A1-F6EECF244321}">
-                <p14:modId xmlns:p14="http://schemas.microsoft.com/office/powerpoint/2010/main" val="1579011935"/>
+                <p14:modId xmlns:p14="http://schemas.microsoft.com/office/powerpoint/2010/main" val="2680276457"/>
               </p:ext>
             </p:extLst>
           </p:nvPr>
@@ -19156,7 +19156,7 @@
                       <a:tailEnd type="none" w="med" len="med"/>
                     </a:lnB>
                     <a:solidFill>
-                      <a:srgbClr val="FFFFFF"/>
+                      <a:srgbClr val="FFFF00"/>
                     </a:solidFill>
                   </a:tcPr>
                 </a:tc>
@@ -19217,7 +19217,7 @@
                       <a:tailEnd type="none" w="med" len="med"/>
                     </a:lnB>
                     <a:solidFill>
-                      <a:srgbClr val="FFFFFF"/>
+                      <a:srgbClr val="FFFF00"/>
                     </a:solidFill>
                   </a:tcPr>
                 </a:tc>
@@ -19278,7 +19278,7 @@
                       <a:tailEnd type="none" w="med" len="med"/>
                     </a:lnB>
                     <a:solidFill>
-                      <a:srgbClr val="FFFFFF"/>
+                      <a:srgbClr val="FFFF00"/>
                     </a:solidFill>
                   </a:tcPr>
                 </a:tc>
@@ -19339,7 +19339,7 @@
                       <a:tailEnd type="none" w="med" len="med"/>
                     </a:lnB>
                     <a:solidFill>
-                      <a:srgbClr val="FFFFFF"/>
+                      <a:srgbClr val="FFFF00"/>
                     </a:solidFill>
                   </a:tcPr>
                 </a:tc>
@@ -19702,7 +19702,23 @@
                   <a:schemeClr val="tx1"/>
                 </a:solidFill>
               </a:rPr>
-              <a:t>8 inputs, 1 numeric target.</a:t>
+              <a:t>8</a:t>
+            </a:r>
+            <a:r>
+              <a:rPr lang="en-US" sz="1600">
+                <a:solidFill>
+                  <a:schemeClr val="tx1"/>
+                </a:solidFill>
+              </a:rPr>
+              <a:t> </a:t>
+            </a:r>
+            <a:r>
+              <a:rPr lang="en-US" sz="1600" dirty="0">
+                <a:solidFill>
+                  <a:schemeClr val="tx1"/>
+                </a:solidFill>
+              </a:rPr>
+              <a:t>inputs, 1 numeric target.</a:t>
             </a:r>
             <a:endParaRPr lang="en-US" sz="1800" dirty="0"/>
           </a:p>

</xml_diff>